<commit_message>
Pipeline-slide: BPP en Concorde als Q3 gemarkeerd, privé naar privaat
BPP en Concorde Career College staan niet in Close, maar Jeroen
bevestigt dat beide in Q3 zijn aangemaakt. Kregen daarom ook het
Q3-label naast hun bestaande Privaat-label, en de bronregel is
aangepast (was: aanmaakdatum onbekend).

Kolomkop en badge "Privé" naar "Privaat": we bedoelen de private
sector (niet-staatsgesubsidieerd), niet persoonlijk/vertrouwelijk.

Co-Authored-By: Claude Sonnet 5 <noreply@anthropic.com>
Claude-Session: https://claude.ai/code/session_01VJXex4xeGziE7UTBLmhoDk
</commit_message>
<xml_diff>
--- a/GTM/board-meeting-q3-2026/deck/eduface-board-q3-2026-bewerkbaar.pptx
+++ b/GTM/board-meeting-q3-2026/deck/eduface-board-q3-2026-bewerkbaar.pptx
@@ -9667,7 +9667,7 @@
                 </a:solidFill>
                 <a:latin typeface="Inter"/>
               </a:rPr>
-              <a:t>Privé</a:t>
+              <a:t>Privaat</a:t>
             </a:r>
           </a:p>
         </p:txBody>
@@ -9920,7 +9920,7 @@
         <p:spPr>
           <a:xfrm>
             <a:off x="4508500" y="1885950"/>
-            <a:ext cx="495300" cy="139700"/>
+            <a:ext cx="622300" cy="139700"/>
           </a:xfrm>
           <a:prstGeom prst="roundRect">
             <a:avLst>
@@ -9966,7 +9966,7 @@
         <p:spPr>
           <a:xfrm>
             <a:off x="4508500" y="1898650"/>
-            <a:ext cx="495300" cy="114300"/>
+            <a:ext cx="622300" cy="114300"/>
           </a:xfrm>
           <a:prstGeom prst="rect">
             <a:avLst/>
@@ -9991,7 +9991,7 @@
                 </a:solidFill>
                 <a:latin typeface="Inter"/>
               </a:rPr>
-              <a:t>PRIVÉ</a:t>
+              <a:t>PRIVAAT</a:t>
             </a:r>
           </a:p>
         </p:txBody>
@@ -10246,7 +10246,7 @@
         <p:spPr>
           <a:xfrm>
             <a:off x="4508500" y="2051050"/>
-            <a:ext cx="495300" cy="139700"/>
+            <a:ext cx="622300" cy="139700"/>
           </a:xfrm>
           <a:prstGeom prst="roundRect">
             <a:avLst>
@@ -10292,7 +10292,7 @@
         <p:spPr>
           <a:xfrm>
             <a:off x="4508500" y="2063750"/>
-            <a:ext cx="495300" cy="114300"/>
+            <a:ext cx="622300" cy="114300"/>
           </a:xfrm>
           <a:prstGeom prst="rect">
             <a:avLst/>
@@ -10317,215 +10317,20 @@
                 </a:solidFill>
                 <a:latin typeface="Inter"/>
               </a:rPr>
-              <a:t>PRIVÉ</a:t>
-            </a:r>
-          </a:p>
-        </p:txBody>
-      </p:sp>
-      <p:sp>
-        <p:nvSpPr>
-          <p:cNvPr id="23" name="TextBox 22"/>
-          <p:cNvSpPr txBox="1"/>
-          <p:nvPr/>
-        </p:nvSpPr>
-        <p:spPr>
-          <a:xfrm>
-            <a:off x="5461000" y="2057400"/>
-            <a:ext cx="571500" cy="152400"/>
-          </a:xfrm>
-          <a:prstGeom prst="rect">
-            <a:avLst/>
-          </a:prstGeom>
-          <a:noFill/>
-        </p:spPr>
-        <p:txBody>
-          <a:bodyPr wrap="square" lIns="0" rIns="0" tIns="0" bIns="0">
-            <a:spAutoFit/>
-          </a:bodyPr>
-          <a:lstStyle/>
-          <a:p>
-            <a:pPr algn="l">
-              <a:lnSpc>
-                <a:spcPct val="115000"/>
-              </a:lnSpc>
-            </a:pPr>
-            <a:r>
-              <a:rPr sz="800" b="0">
-                <a:solidFill>
-                  <a:srgbClr val="5B7480"/>
-                </a:solidFill>
-                <a:latin typeface="Inter"/>
-              </a:rPr>
-              <a:t>n.b.</a:t>
-            </a:r>
-          </a:p>
-        </p:txBody>
-      </p:sp>
-      <p:sp>
-        <p:nvSpPr>
-          <p:cNvPr id="24" name="TextBox 23"/>
-          <p:cNvSpPr txBox="1"/>
-          <p:nvPr/>
-        </p:nvSpPr>
-        <p:spPr>
-          <a:xfrm>
-            <a:off x="8572500" y="2057400"/>
-            <a:ext cx="1460500" cy="152400"/>
-          </a:xfrm>
-          <a:prstGeom prst="rect">
-            <a:avLst/>
-          </a:prstGeom>
-          <a:noFill/>
-        </p:spPr>
-        <p:txBody>
-          <a:bodyPr wrap="square" lIns="0" rIns="0" tIns="0" bIns="0">
-            <a:spAutoFit/>
-          </a:bodyPr>
-          <a:lstStyle/>
-          <a:p>
-            <a:pPr algn="r">
-              <a:lnSpc>
-                <a:spcPct val="115000"/>
-              </a:lnSpc>
-            </a:pPr>
-            <a:r>
-              <a:rPr sz="950" b="0">
-                <a:solidFill>
-                  <a:srgbClr val="002333"/>
-                </a:solidFill>
-                <a:latin typeface="Inter"/>
-              </a:rPr>
-              <a:t>€400.000</a:t>
-            </a:r>
-          </a:p>
-        </p:txBody>
-      </p:sp>
-      <p:sp>
-        <p:nvSpPr>
-          <p:cNvPr id="25" name="TextBox 24"/>
-          <p:cNvSpPr txBox="1"/>
-          <p:nvPr/>
-        </p:nvSpPr>
-        <p:spPr>
-          <a:xfrm>
-            <a:off x="10223500" y="2057400"/>
-            <a:ext cx="1206500" cy="152400"/>
-          </a:xfrm>
-          <a:prstGeom prst="rect">
-            <a:avLst/>
-          </a:prstGeom>
-          <a:noFill/>
-        </p:spPr>
-        <p:txBody>
-          <a:bodyPr wrap="square" lIns="0" rIns="0" tIns="0" bIns="0">
-            <a:spAutoFit/>
-          </a:bodyPr>
-          <a:lstStyle/>
-          <a:p>
-            <a:pPr algn="r">
-              <a:lnSpc>
-                <a:spcPct val="115000"/>
-              </a:lnSpc>
-            </a:pPr>
-            <a:r>
-              <a:rPr sz="950" b="0">
-                <a:solidFill>
-                  <a:srgbClr val="002333"/>
-                </a:solidFill>
-                <a:latin typeface="Inter"/>
-              </a:rPr>
-              <a:t>10%</a:t>
-            </a:r>
-          </a:p>
-        </p:txBody>
-      </p:sp>
-      <p:sp>
-        <p:nvSpPr>
-          <p:cNvPr id="26" name="TextBox 25"/>
-          <p:cNvSpPr txBox="1"/>
-          <p:nvPr/>
-        </p:nvSpPr>
-        <p:spPr>
-          <a:xfrm>
-            <a:off x="762000" y="2222500"/>
-            <a:ext cx="3048000" cy="152400"/>
-          </a:xfrm>
-          <a:prstGeom prst="rect">
-            <a:avLst/>
-          </a:prstGeom>
-          <a:noFill/>
-        </p:spPr>
-        <p:txBody>
-          <a:bodyPr wrap="square" lIns="0" rIns="0" tIns="0" bIns="0">
-            <a:spAutoFit/>
-          </a:bodyPr>
-          <a:lstStyle/>
-          <a:p>
-            <a:pPr algn="l">
-              <a:lnSpc>
-                <a:spcPct val="115000"/>
-              </a:lnSpc>
-            </a:pPr>
-            <a:r>
-              <a:rPr sz="950" b="0">
-                <a:solidFill>
-                  <a:srgbClr val="002333"/>
-                </a:solidFill>
-                <a:latin typeface="Inter"/>
-              </a:rPr>
-              <a:t>Rijksuniversiteit Groningen</a:t>
-            </a:r>
-          </a:p>
-        </p:txBody>
-      </p:sp>
-      <p:sp>
-        <p:nvSpPr>
-          <p:cNvPr id="27" name="TextBox 26"/>
-          <p:cNvSpPr txBox="1"/>
-          <p:nvPr/>
-        </p:nvSpPr>
-        <p:spPr>
-          <a:xfrm>
-            <a:off x="3937000" y="2222500"/>
-            <a:ext cx="444500" cy="152400"/>
-          </a:xfrm>
-          <a:prstGeom prst="rect">
-            <a:avLst/>
-          </a:prstGeom>
-          <a:noFill/>
-        </p:spPr>
-        <p:txBody>
-          <a:bodyPr wrap="square" lIns="0" rIns="0" tIns="0" bIns="0">
-            <a:spAutoFit/>
-          </a:bodyPr>
-          <a:lstStyle/>
-          <a:p>
-            <a:pPr algn="l">
-              <a:lnSpc>
-                <a:spcPct val="115000"/>
-              </a:lnSpc>
-            </a:pPr>
-            <a:r>
-              <a:rPr sz="950" b="0">
-                <a:solidFill>
-                  <a:srgbClr val="5B7480"/>
-                </a:solidFill>
-                <a:latin typeface="Inter"/>
-              </a:rPr>
-              <a:t>NL</a:t>
-            </a:r>
-          </a:p>
-        </p:txBody>
-      </p:sp>
-      <p:sp>
-        <p:nvSpPr>
-          <p:cNvPr id="28" name="Rounded Rectangle 27"/>
+              <a:t>PRIVAAT</a:t>
+            </a:r>
+          </a:p>
+        </p:txBody>
+      </p:sp>
+      <p:sp>
+        <p:nvSpPr>
+          <p:cNvPr id="23" name="Rounded Rectangle 22"/>
           <p:cNvSpPr/>
           <p:nvPr/>
         </p:nvSpPr>
         <p:spPr>
           <a:xfrm>
-            <a:off x="5461000" y="2216150"/>
+            <a:off x="5461000" y="2051050"/>
             <a:ext cx="330200" cy="139700"/>
           </a:xfrm>
           <a:prstGeom prst="roundRect">
@@ -10565,7 +10370,248 @@
       </p:sp>
       <p:sp>
         <p:nvSpPr>
-          <p:cNvPr id="29" name="TextBox 28"/>
+          <p:cNvPr id="24" name="TextBox 23"/>
+          <p:cNvSpPr txBox="1"/>
+          <p:nvPr/>
+        </p:nvSpPr>
+        <p:spPr>
+          <a:xfrm>
+            <a:off x="5461000" y="2063750"/>
+            <a:ext cx="330200" cy="114300"/>
+          </a:xfrm>
+          <a:prstGeom prst="rect">
+            <a:avLst/>
+          </a:prstGeom>
+          <a:noFill/>
+        </p:spPr>
+        <p:txBody>
+          <a:bodyPr wrap="square" lIns="0" rIns="0" tIns="0" bIns="0">
+            <a:spAutoFit/>
+          </a:bodyPr>
+          <a:lstStyle/>
+          <a:p>
+            <a:pPr algn="ctr">
+              <a:lnSpc>
+                <a:spcPct val="115000"/>
+              </a:lnSpc>
+            </a:pPr>
+            <a:r>
+              <a:rPr sz="650" b="1">
+                <a:solidFill>
+                  <a:srgbClr val="E07B00"/>
+                </a:solidFill>
+                <a:latin typeface="Inter"/>
+              </a:rPr>
+              <a:t>Q3</a:t>
+            </a:r>
+          </a:p>
+        </p:txBody>
+      </p:sp>
+      <p:sp>
+        <p:nvSpPr>
+          <p:cNvPr id="25" name="TextBox 24"/>
+          <p:cNvSpPr txBox="1"/>
+          <p:nvPr/>
+        </p:nvSpPr>
+        <p:spPr>
+          <a:xfrm>
+            <a:off x="8572500" y="2057400"/>
+            <a:ext cx="1460500" cy="152400"/>
+          </a:xfrm>
+          <a:prstGeom prst="rect">
+            <a:avLst/>
+          </a:prstGeom>
+          <a:noFill/>
+        </p:spPr>
+        <p:txBody>
+          <a:bodyPr wrap="square" lIns="0" rIns="0" tIns="0" bIns="0">
+            <a:spAutoFit/>
+          </a:bodyPr>
+          <a:lstStyle/>
+          <a:p>
+            <a:pPr algn="r">
+              <a:lnSpc>
+                <a:spcPct val="115000"/>
+              </a:lnSpc>
+            </a:pPr>
+            <a:r>
+              <a:rPr sz="950" b="0">
+                <a:solidFill>
+                  <a:srgbClr val="002333"/>
+                </a:solidFill>
+                <a:latin typeface="Inter"/>
+              </a:rPr>
+              <a:t>€400.000</a:t>
+            </a:r>
+          </a:p>
+        </p:txBody>
+      </p:sp>
+      <p:sp>
+        <p:nvSpPr>
+          <p:cNvPr id="26" name="TextBox 25"/>
+          <p:cNvSpPr txBox="1"/>
+          <p:nvPr/>
+        </p:nvSpPr>
+        <p:spPr>
+          <a:xfrm>
+            <a:off x="10223500" y="2057400"/>
+            <a:ext cx="1206500" cy="152400"/>
+          </a:xfrm>
+          <a:prstGeom prst="rect">
+            <a:avLst/>
+          </a:prstGeom>
+          <a:noFill/>
+        </p:spPr>
+        <p:txBody>
+          <a:bodyPr wrap="square" lIns="0" rIns="0" tIns="0" bIns="0">
+            <a:spAutoFit/>
+          </a:bodyPr>
+          <a:lstStyle/>
+          <a:p>
+            <a:pPr algn="r">
+              <a:lnSpc>
+                <a:spcPct val="115000"/>
+              </a:lnSpc>
+            </a:pPr>
+            <a:r>
+              <a:rPr sz="950" b="0">
+                <a:solidFill>
+                  <a:srgbClr val="002333"/>
+                </a:solidFill>
+                <a:latin typeface="Inter"/>
+              </a:rPr>
+              <a:t>10%</a:t>
+            </a:r>
+          </a:p>
+        </p:txBody>
+      </p:sp>
+      <p:sp>
+        <p:nvSpPr>
+          <p:cNvPr id="27" name="TextBox 26"/>
+          <p:cNvSpPr txBox="1"/>
+          <p:nvPr/>
+        </p:nvSpPr>
+        <p:spPr>
+          <a:xfrm>
+            <a:off x="762000" y="2222500"/>
+            <a:ext cx="3048000" cy="152400"/>
+          </a:xfrm>
+          <a:prstGeom prst="rect">
+            <a:avLst/>
+          </a:prstGeom>
+          <a:noFill/>
+        </p:spPr>
+        <p:txBody>
+          <a:bodyPr wrap="square" lIns="0" rIns="0" tIns="0" bIns="0">
+            <a:spAutoFit/>
+          </a:bodyPr>
+          <a:lstStyle/>
+          <a:p>
+            <a:pPr algn="l">
+              <a:lnSpc>
+                <a:spcPct val="115000"/>
+              </a:lnSpc>
+            </a:pPr>
+            <a:r>
+              <a:rPr sz="950" b="0">
+                <a:solidFill>
+                  <a:srgbClr val="002333"/>
+                </a:solidFill>
+                <a:latin typeface="Inter"/>
+              </a:rPr>
+              <a:t>Rijksuniversiteit Groningen</a:t>
+            </a:r>
+          </a:p>
+        </p:txBody>
+      </p:sp>
+      <p:sp>
+        <p:nvSpPr>
+          <p:cNvPr id="28" name="TextBox 27"/>
+          <p:cNvSpPr txBox="1"/>
+          <p:nvPr/>
+        </p:nvSpPr>
+        <p:spPr>
+          <a:xfrm>
+            <a:off x="3937000" y="2222500"/>
+            <a:ext cx="444500" cy="152400"/>
+          </a:xfrm>
+          <a:prstGeom prst="rect">
+            <a:avLst/>
+          </a:prstGeom>
+          <a:noFill/>
+        </p:spPr>
+        <p:txBody>
+          <a:bodyPr wrap="square" lIns="0" rIns="0" tIns="0" bIns="0">
+            <a:spAutoFit/>
+          </a:bodyPr>
+          <a:lstStyle/>
+          <a:p>
+            <a:pPr algn="l">
+              <a:lnSpc>
+                <a:spcPct val="115000"/>
+              </a:lnSpc>
+            </a:pPr>
+            <a:r>
+              <a:rPr sz="950" b="0">
+                <a:solidFill>
+                  <a:srgbClr val="5B7480"/>
+                </a:solidFill>
+                <a:latin typeface="Inter"/>
+              </a:rPr>
+              <a:t>NL</a:t>
+            </a:r>
+          </a:p>
+        </p:txBody>
+      </p:sp>
+      <p:sp>
+        <p:nvSpPr>
+          <p:cNvPr id="29" name="Rounded Rectangle 28"/>
+          <p:cNvSpPr/>
+          <p:nvPr/>
+        </p:nvSpPr>
+        <p:spPr>
+          <a:xfrm>
+            <a:off x="5461000" y="2216150"/>
+            <a:ext cx="330200" cy="139700"/>
+          </a:xfrm>
+          <a:prstGeom prst="roundRect">
+            <a:avLst>
+              <a:gd name="adj" fmla="val 27272"/>
+            </a:avLst>
+          </a:prstGeom>
+          <a:solidFill>
+            <a:srgbClr val="FDF0DF"/>
+          </a:solidFill>
+          <a:ln>
+            <a:noFill/>
+          </a:ln>
+          <a:effectLst/>
+        </p:spPr>
+        <p:style>
+          <a:lnRef idx="1">
+            <a:schemeClr val="accent1"/>
+          </a:lnRef>
+          <a:fillRef idx="3">
+            <a:schemeClr val="accent1"/>
+          </a:fillRef>
+          <a:effectRef idx="2">
+            <a:schemeClr val="accent1"/>
+          </a:effectRef>
+          <a:fontRef idx="minor">
+            <a:schemeClr val="lt1"/>
+          </a:fontRef>
+        </p:style>
+        <p:txBody>
+          <a:bodyPr rtlCol="0" anchor="ctr"/>
+          <a:lstStyle/>
+          <a:p>
+            <a:pPr algn="ctr"/>
+          </a:p>
+        </p:txBody>
+      </p:sp>
+      <p:sp>
+        <p:nvSpPr>
+          <p:cNvPr id="30" name="TextBox 29"/>
           <p:cNvSpPr txBox="1"/>
           <p:nvPr/>
         </p:nvSpPr>
@@ -10604,7 +10650,7 @@
       </p:sp>
       <p:sp>
         <p:nvSpPr>
-          <p:cNvPr id="30" name="TextBox 29"/>
+          <p:cNvPr id="31" name="TextBox 30"/>
           <p:cNvSpPr txBox="1"/>
           <p:nvPr/>
         </p:nvSpPr>
@@ -10643,7 +10689,7 @@
       </p:sp>
       <p:sp>
         <p:nvSpPr>
-          <p:cNvPr id="31" name="TextBox 30"/>
+          <p:cNvPr id="32" name="TextBox 31"/>
           <p:cNvSpPr txBox="1"/>
           <p:nvPr/>
         </p:nvSpPr>
@@ -10682,7 +10728,7 @@
       </p:sp>
       <p:sp>
         <p:nvSpPr>
-          <p:cNvPr id="32" name="TextBox 31"/>
+          <p:cNvPr id="33" name="TextBox 32"/>
           <p:cNvSpPr txBox="1"/>
           <p:nvPr/>
         </p:nvSpPr>
@@ -10721,7 +10767,7 @@
       </p:sp>
       <p:sp>
         <p:nvSpPr>
-          <p:cNvPr id="33" name="TextBox 32"/>
+          <p:cNvPr id="34" name="TextBox 33"/>
           <p:cNvSpPr txBox="1"/>
           <p:nvPr/>
         </p:nvSpPr>
@@ -10760,14 +10806,14 @@
       </p:sp>
       <p:sp>
         <p:nvSpPr>
-          <p:cNvPr id="34" name="Rounded Rectangle 33"/>
+          <p:cNvPr id="35" name="Rounded Rectangle 34"/>
           <p:cNvSpPr/>
           <p:nvPr/>
         </p:nvSpPr>
         <p:spPr>
           <a:xfrm>
             <a:off x="4508500" y="2381250"/>
-            <a:ext cx="495300" cy="139700"/>
+            <a:ext cx="622300" cy="139700"/>
           </a:xfrm>
           <a:prstGeom prst="roundRect">
             <a:avLst>
@@ -10806,14 +10852,14 @@
       </p:sp>
       <p:sp>
         <p:nvSpPr>
-          <p:cNvPr id="35" name="TextBox 34"/>
+          <p:cNvPr id="36" name="TextBox 35"/>
           <p:cNvSpPr txBox="1"/>
           <p:nvPr/>
         </p:nvSpPr>
         <p:spPr>
           <a:xfrm>
             <a:off x="4508500" y="2393950"/>
-            <a:ext cx="495300" cy="114300"/>
+            <a:ext cx="622300" cy="114300"/>
           </a:xfrm>
           <a:prstGeom prst="rect">
             <a:avLst/>
@@ -10838,14 +10884,14 @@
                 </a:solidFill>
                 <a:latin typeface="Inter"/>
               </a:rPr>
-              <a:t>PRIVÉ</a:t>
-            </a:r>
-          </a:p>
-        </p:txBody>
-      </p:sp>
-      <p:sp>
-        <p:nvSpPr>
-          <p:cNvPr id="36" name="Rounded Rectangle 35"/>
+              <a:t>PRIVAAT</a:t>
+            </a:r>
+          </a:p>
+        </p:txBody>
+      </p:sp>
+      <p:sp>
+        <p:nvSpPr>
+          <p:cNvPr id="37" name="Rounded Rectangle 36"/>
           <p:cNvSpPr/>
           <p:nvPr/>
         </p:nvSpPr>
@@ -10891,7 +10937,7 @@
       </p:sp>
       <p:sp>
         <p:nvSpPr>
-          <p:cNvPr id="37" name="TextBox 36"/>
+          <p:cNvPr id="38" name="TextBox 37"/>
           <p:cNvSpPr txBox="1"/>
           <p:nvPr/>
         </p:nvSpPr>
@@ -10930,7 +10976,7 @@
       </p:sp>
       <p:sp>
         <p:nvSpPr>
-          <p:cNvPr id="38" name="TextBox 37"/>
+          <p:cNvPr id="39" name="TextBox 38"/>
           <p:cNvSpPr txBox="1"/>
           <p:nvPr/>
         </p:nvSpPr>
@@ -10969,7 +11015,7 @@
       </p:sp>
       <p:sp>
         <p:nvSpPr>
-          <p:cNvPr id="39" name="TextBox 38"/>
+          <p:cNvPr id="40" name="TextBox 39"/>
           <p:cNvSpPr txBox="1"/>
           <p:nvPr/>
         </p:nvSpPr>
@@ -11008,7 +11054,7 @@
       </p:sp>
       <p:sp>
         <p:nvSpPr>
-          <p:cNvPr id="40" name="TextBox 39"/>
+          <p:cNvPr id="41" name="TextBox 40"/>
           <p:cNvSpPr txBox="1"/>
           <p:nvPr/>
         </p:nvSpPr>
@@ -11047,7 +11093,7 @@
       </p:sp>
       <p:sp>
         <p:nvSpPr>
-          <p:cNvPr id="41" name="TextBox 40"/>
+          <p:cNvPr id="42" name="TextBox 41"/>
           <p:cNvSpPr txBox="1"/>
           <p:nvPr/>
         </p:nvSpPr>
@@ -11086,7 +11132,7 @@
       </p:sp>
       <p:sp>
         <p:nvSpPr>
-          <p:cNvPr id="42" name="Rounded Rectangle 41"/>
+          <p:cNvPr id="43" name="Rounded Rectangle 42"/>
           <p:cNvSpPr/>
           <p:nvPr/>
         </p:nvSpPr>
@@ -11132,7 +11178,7 @@
       </p:sp>
       <p:sp>
         <p:nvSpPr>
-          <p:cNvPr id="43" name="TextBox 42"/>
+          <p:cNvPr id="44" name="TextBox 43"/>
           <p:cNvSpPr txBox="1"/>
           <p:nvPr/>
         </p:nvSpPr>
@@ -11171,7 +11217,7 @@
       </p:sp>
       <p:sp>
         <p:nvSpPr>
-          <p:cNvPr id="44" name="TextBox 43"/>
+          <p:cNvPr id="45" name="TextBox 44"/>
           <p:cNvSpPr txBox="1"/>
           <p:nvPr/>
         </p:nvSpPr>
@@ -11210,7 +11256,7 @@
       </p:sp>
       <p:sp>
         <p:nvSpPr>
-          <p:cNvPr id="45" name="TextBox 44"/>
+          <p:cNvPr id="46" name="TextBox 45"/>
           <p:cNvSpPr txBox="1"/>
           <p:nvPr/>
         </p:nvSpPr>
@@ -11249,7 +11295,7 @@
       </p:sp>
       <p:sp>
         <p:nvSpPr>
-          <p:cNvPr id="46" name="TextBox 45"/>
+          <p:cNvPr id="47" name="TextBox 46"/>
           <p:cNvSpPr txBox="1"/>
           <p:nvPr/>
         </p:nvSpPr>
@@ -11288,7 +11334,7 @@
       </p:sp>
       <p:sp>
         <p:nvSpPr>
-          <p:cNvPr id="47" name="TextBox 46"/>
+          <p:cNvPr id="48" name="TextBox 47"/>
           <p:cNvSpPr txBox="1"/>
           <p:nvPr/>
         </p:nvSpPr>
@@ -11327,7 +11373,7 @@
       </p:sp>
       <p:sp>
         <p:nvSpPr>
-          <p:cNvPr id="48" name="Rounded Rectangle 47"/>
+          <p:cNvPr id="49" name="Rounded Rectangle 48"/>
           <p:cNvSpPr/>
           <p:nvPr/>
         </p:nvSpPr>
@@ -11373,7 +11419,7 @@
       </p:sp>
       <p:sp>
         <p:nvSpPr>
-          <p:cNvPr id="49" name="TextBox 48"/>
+          <p:cNvPr id="50" name="TextBox 49"/>
           <p:cNvSpPr txBox="1"/>
           <p:nvPr/>
         </p:nvSpPr>
@@ -11412,7 +11458,7 @@
       </p:sp>
       <p:sp>
         <p:nvSpPr>
-          <p:cNvPr id="50" name="TextBox 49"/>
+          <p:cNvPr id="51" name="TextBox 50"/>
           <p:cNvSpPr txBox="1"/>
           <p:nvPr/>
         </p:nvSpPr>
@@ -11451,7 +11497,7 @@
       </p:sp>
       <p:sp>
         <p:nvSpPr>
-          <p:cNvPr id="51" name="TextBox 50"/>
+          <p:cNvPr id="52" name="TextBox 51"/>
           <p:cNvSpPr txBox="1"/>
           <p:nvPr/>
         </p:nvSpPr>
@@ -11490,7 +11536,7 @@
       </p:sp>
       <p:sp>
         <p:nvSpPr>
-          <p:cNvPr id="52" name="TextBox 51"/>
+          <p:cNvPr id="53" name="TextBox 52"/>
           <p:cNvSpPr txBox="1"/>
           <p:nvPr/>
         </p:nvSpPr>
@@ -11529,7 +11575,7 @@
       </p:sp>
       <p:sp>
         <p:nvSpPr>
-          <p:cNvPr id="53" name="TextBox 52"/>
+          <p:cNvPr id="54" name="TextBox 53"/>
           <p:cNvSpPr txBox="1"/>
           <p:nvPr/>
         </p:nvSpPr>
@@ -11568,14 +11614,14 @@
       </p:sp>
       <p:sp>
         <p:nvSpPr>
-          <p:cNvPr id="54" name="Rounded Rectangle 53"/>
+          <p:cNvPr id="55" name="Rounded Rectangle 54"/>
           <p:cNvSpPr/>
           <p:nvPr/>
         </p:nvSpPr>
         <p:spPr>
           <a:xfrm>
             <a:off x="4508500" y="2876550"/>
-            <a:ext cx="495300" cy="139700"/>
+            <a:ext cx="622300" cy="139700"/>
           </a:xfrm>
           <a:prstGeom prst="roundRect">
             <a:avLst>
@@ -11614,14 +11660,14 @@
       </p:sp>
       <p:sp>
         <p:nvSpPr>
-          <p:cNvPr id="55" name="TextBox 54"/>
+          <p:cNvPr id="56" name="TextBox 55"/>
           <p:cNvSpPr txBox="1"/>
           <p:nvPr/>
         </p:nvSpPr>
         <p:spPr>
           <a:xfrm>
             <a:off x="4508500" y="2889250"/>
-            <a:ext cx="495300" cy="114300"/>
+            <a:ext cx="622300" cy="114300"/>
           </a:xfrm>
           <a:prstGeom prst="rect">
             <a:avLst/>
@@ -11646,215 +11692,20 @@
                 </a:solidFill>
                 <a:latin typeface="Inter"/>
               </a:rPr>
-              <a:t>PRIVÉ</a:t>
-            </a:r>
-          </a:p>
-        </p:txBody>
-      </p:sp>
-      <p:sp>
-        <p:nvSpPr>
-          <p:cNvPr id="56" name="TextBox 55"/>
-          <p:cNvSpPr txBox="1"/>
-          <p:nvPr/>
-        </p:nvSpPr>
-        <p:spPr>
-          <a:xfrm>
-            <a:off x="5461000" y="2882900"/>
-            <a:ext cx="571500" cy="152400"/>
-          </a:xfrm>
-          <a:prstGeom prst="rect">
-            <a:avLst/>
-          </a:prstGeom>
-          <a:noFill/>
-        </p:spPr>
-        <p:txBody>
-          <a:bodyPr wrap="square" lIns="0" rIns="0" tIns="0" bIns="0">
-            <a:spAutoFit/>
-          </a:bodyPr>
-          <a:lstStyle/>
-          <a:p>
-            <a:pPr algn="l">
-              <a:lnSpc>
-                <a:spcPct val="115000"/>
-              </a:lnSpc>
-            </a:pPr>
-            <a:r>
-              <a:rPr sz="800" b="0">
-                <a:solidFill>
-                  <a:srgbClr val="5B7480"/>
-                </a:solidFill>
-                <a:latin typeface="Inter"/>
-              </a:rPr>
-              <a:t>n.b.</a:t>
-            </a:r>
-          </a:p>
-        </p:txBody>
-      </p:sp>
-      <p:sp>
-        <p:nvSpPr>
-          <p:cNvPr id="57" name="TextBox 56"/>
-          <p:cNvSpPr txBox="1"/>
-          <p:nvPr/>
-        </p:nvSpPr>
-        <p:spPr>
-          <a:xfrm>
-            <a:off x="8572500" y="2882900"/>
-            <a:ext cx="1460500" cy="152400"/>
-          </a:xfrm>
-          <a:prstGeom prst="rect">
-            <a:avLst/>
-          </a:prstGeom>
-          <a:noFill/>
-        </p:spPr>
-        <p:txBody>
-          <a:bodyPr wrap="square" lIns="0" rIns="0" tIns="0" bIns="0">
-            <a:spAutoFit/>
-          </a:bodyPr>
-          <a:lstStyle/>
-          <a:p>
-            <a:pPr algn="r">
-              <a:lnSpc>
-                <a:spcPct val="115000"/>
-              </a:lnSpc>
-            </a:pPr>
-            <a:r>
-              <a:rPr sz="950" b="0">
-                <a:solidFill>
-                  <a:srgbClr val="002333"/>
-                </a:solidFill>
-                <a:latin typeface="Inter"/>
-              </a:rPr>
-              <a:t>€200.000</a:t>
-            </a:r>
-          </a:p>
-        </p:txBody>
-      </p:sp>
-      <p:sp>
-        <p:nvSpPr>
-          <p:cNvPr id="58" name="TextBox 57"/>
-          <p:cNvSpPr txBox="1"/>
-          <p:nvPr/>
-        </p:nvSpPr>
-        <p:spPr>
-          <a:xfrm>
-            <a:off x="10223500" y="2882900"/>
-            <a:ext cx="1206500" cy="152400"/>
-          </a:xfrm>
-          <a:prstGeom prst="rect">
-            <a:avLst/>
-          </a:prstGeom>
-          <a:noFill/>
-        </p:spPr>
-        <p:txBody>
-          <a:bodyPr wrap="square" lIns="0" rIns="0" tIns="0" bIns="0">
-            <a:spAutoFit/>
-          </a:bodyPr>
-          <a:lstStyle/>
-          <a:p>
-            <a:pPr algn="r">
-              <a:lnSpc>
-                <a:spcPct val="115000"/>
-              </a:lnSpc>
-            </a:pPr>
-            <a:r>
-              <a:rPr sz="950" b="0">
-                <a:solidFill>
-                  <a:srgbClr val="002333"/>
-                </a:solidFill>
-                <a:latin typeface="Inter"/>
-              </a:rPr>
-              <a:t>15%</a:t>
-            </a:r>
-          </a:p>
-        </p:txBody>
-      </p:sp>
-      <p:sp>
-        <p:nvSpPr>
-          <p:cNvPr id="59" name="TextBox 58"/>
-          <p:cNvSpPr txBox="1"/>
-          <p:nvPr/>
-        </p:nvSpPr>
-        <p:spPr>
-          <a:xfrm>
-            <a:off x="762000" y="3048000"/>
-            <a:ext cx="3048000" cy="152400"/>
-          </a:xfrm>
-          <a:prstGeom prst="rect">
-            <a:avLst/>
-          </a:prstGeom>
-          <a:noFill/>
-        </p:spPr>
-        <p:txBody>
-          <a:bodyPr wrap="square" lIns="0" rIns="0" tIns="0" bIns="0">
-            <a:spAutoFit/>
-          </a:bodyPr>
-          <a:lstStyle/>
-          <a:p>
-            <a:pPr algn="l">
-              <a:lnSpc>
-                <a:spcPct val="115000"/>
-              </a:lnSpc>
-            </a:pPr>
-            <a:r>
-              <a:rPr sz="950" b="0">
-                <a:solidFill>
-                  <a:srgbClr val="002333"/>
-                </a:solidFill>
-                <a:latin typeface="Inter"/>
-              </a:rPr>
-              <a:t>Goldsmiths</a:t>
-            </a:r>
-          </a:p>
-        </p:txBody>
-      </p:sp>
-      <p:sp>
-        <p:nvSpPr>
-          <p:cNvPr id="60" name="TextBox 59"/>
-          <p:cNvSpPr txBox="1"/>
-          <p:nvPr/>
-        </p:nvSpPr>
-        <p:spPr>
-          <a:xfrm>
-            <a:off x="3937000" y="3048000"/>
-            <a:ext cx="444500" cy="152400"/>
-          </a:xfrm>
-          <a:prstGeom prst="rect">
-            <a:avLst/>
-          </a:prstGeom>
-          <a:noFill/>
-        </p:spPr>
-        <p:txBody>
-          <a:bodyPr wrap="square" lIns="0" rIns="0" tIns="0" bIns="0">
-            <a:spAutoFit/>
-          </a:bodyPr>
-          <a:lstStyle/>
-          <a:p>
-            <a:pPr algn="l">
-              <a:lnSpc>
-                <a:spcPct val="115000"/>
-              </a:lnSpc>
-            </a:pPr>
-            <a:r>
-              <a:rPr sz="950" b="0">
-                <a:solidFill>
-                  <a:srgbClr val="5B7480"/>
-                </a:solidFill>
-                <a:latin typeface="Inter"/>
-              </a:rPr>
-              <a:t>UK</a:t>
-            </a:r>
-          </a:p>
-        </p:txBody>
-      </p:sp>
-      <p:sp>
-        <p:nvSpPr>
-          <p:cNvPr id="61" name="Rounded Rectangle 60"/>
+              <a:t>PRIVAAT</a:t>
+            </a:r>
+          </a:p>
+        </p:txBody>
+      </p:sp>
+      <p:sp>
+        <p:nvSpPr>
+          <p:cNvPr id="57" name="Rounded Rectangle 56"/>
           <p:cNvSpPr/>
           <p:nvPr/>
         </p:nvSpPr>
         <p:spPr>
           <a:xfrm>
-            <a:off x="5461000" y="3041650"/>
+            <a:off x="5461000" y="2876550"/>
             <a:ext cx="330200" cy="139700"/>
           </a:xfrm>
           <a:prstGeom prst="roundRect">
@@ -11894,7 +11745,248 @@
       </p:sp>
       <p:sp>
         <p:nvSpPr>
+          <p:cNvPr id="58" name="TextBox 57"/>
+          <p:cNvSpPr txBox="1"/>
+          <p:nvPr/>
+        </p:nvSpPr>
+        <p:spPr>
+          <a:xfrm>
+            <a:off x="5461000" y="2889250"/>
+            <a:ext cx="330200" cy="114300"/>
+          </a:xfrm>
+          <a:prstGeom prst="rect">
+            <a:avLst/>
+          </a:prstGeom>
+          <a:noFill/>
+        </p:spPr>
+        <p:txBody>
+          <a:bodyPr wrap="square" lIns="0" rIns="0" tIns="0" bIns="0">
+            <a:spAutoFit/>
+          </a:bodyPr>
+          <a:lstStyle/>
+          <a:p>
+            <a:pPr algn="ctr">
+              <a:lnSpc>
+                <a:spcPct val="115000"/>
+              </a:lnSpc>
+            </a:pPr>
+            <a:r>
+              <a:rPr sz="650" b="1">
+                <a:solidFill>
+                  <a:srgbClr val="E07B00"/>
+                </a:solidFill>
+                <a:latin typeface="Inter"/>
+              </a:rPr>
+              <a:t>Q3</a:t>
+            </a:r>
+          </a:p>
+        </p:txBody>
+      </p:sp>
+      <p:sp>
+        <p:nvSpPr>
+          <p:cNvPr id="59" name="TextBox 58"/>
+          <p:cNvSpPr txBox="1"/>
+          <p:nvPr/>
+        </p:nvSpPr>
+        <p:spPr>
+          <a:xfrm>
+            <a:off x="8572500" y="2882900"/>
+            <a:ext cx="1460500" cy="152400"/>
+          </a:xfrm>
+          <a:prstGeom prst="rect">
+            <a:avLst/>
+          </a:prstGeom>
+          <a:noFill/>
+        </p:spPr>
+        <p:txBody>
+          <a:bodyPr wrap="square" lIns="0" rIns="0" tIns="0" bIns="0">
+            <a:spAutoFit/>
+          </a:bodyPr>
+          <a:lstStyle/>
+          <a:p>
+            <a:pPr algn="r">
+              <a:lnSpc>
+                <a:spcPct val="115000"/>
+              </a:lnSpc>
+            </a:pPr>
+            <a:r>
+              <a:rPr sz="950" b="0">
+                <a:solidFill>
+                  <a:srgbClr val="002333"/>
+                </a:solidFill>
+                <a:latin typeface="Inter"/>
+              </a:rPr>
+              <a:t>€200.000</a:t>
+            </a:r>
+          </a:p>
+        </p:txBody>
+      </p:sp>
+      <p:sp>
+        <p:nvSpPr>
+          <p:cNvPr id="60" name="TextBox 59"/>
+          <p:cNvSpPr txBox="1"/>
+          <p:nvPr/>
+        </p:nvSpPr>
+        <p:spPr>
+          <a:xfrm>
+            <a:off x="10223500" y="2882900"/>
+            <a:ext cx="1206500" cy="152400"/>
+          </a:xfrm>
+          <a:prstGeom prst="rect">
+            <a:avLst/>
+          </a:prstGeom>
+          <a:noFill/>
+        </p:spPr>
+        <p:txBody>
+          <a:bodyPr wrap="square" lIns="0" rIns="0" tIns="0" bIns="0">
+            <a:spAutoFit/>
+          </a:bodyPr>
+          <a:lstStyle/>
+          <a:p>
+            <a:pPr algn="r">
+              <a:lnSpc>
+                <a:spcPct val="115000"/>
+              </a:lnSpc>
+            </a:pPr>
+            <a:r>
+              <a:rPr sz="950" b="0">
+                <a:solidFill>
+                  <a:srgbClr val="002333"/>
+                </a:solidFill>
+                <a:latin typeface="Inter"/>
+              </a:rPr>
+              <a:t>15%</a:t>
+            </a:r>
+          </a:p>
+        </p:txBody>
+      </p:sp>
+      <p:sp>
+        <p:nvSpPr>
+          <p:cNvPr id="61" name="TextBox 60"/>
+          <p:cNvSpPr txBox="1"/>
+          <p:nvPr/>
+        </p:nvSpPr>
+        <p:spPr>
+          <a:xfrm>
+            <a:off x="762000" y="3048000"/>
+            <a:ext cx="3048000" cy="152400"/>
+          </a:xfrm>
+          <a:prstGeom prst="rect">
+            <a:avLst/>
+          </a:prstGeom>
+          <a:noFill/>
+        </p:spPr>
+        <p:txBody>
+          <a:bodyPr wrap="square" lIns="0" rIns="0" tIns="0" bIns="0">
+            <a:spAutoFit/>
+          </a:bodyPr>
+          <a:lstStyle/>
+          <a:p>
+            <a:pPr algn="l">
+              <a:lnSpc>
+                <a:spcPct val="115000"/>
+              </a:lnSpc>
+            </a:pPr>
+            <a:r>
+              <a:rPr sz="950" b="0">
+                <a:solidFill>
+                  <a:srgbClr val="002333"/>
+                </a:solidFill>
+                <a:latin typeface="Inter"/>
+              </a:rPr>
+              <a:t>Goldsmiths</a:t>
+            </a:r>
+          </a:p>
+        </p:txBody>
+      </p:sp>
+      <p:sp>
+        <p:nvSpPr>
           <p:cNvPr id="62" name="TextBox 61"/>
+          <p:cNvSpPr txBox="1"/>
+          <p:nvPr/>
+        </p:nvSpPr>
+        <p:spPr>
+          <a:xfrm>
+            <a:off x="3937000" y="3048000"/>
+            <a:ext cx="444500" cy="152400"/>
+          </a:xfrm>
+          <a:prstGeom prst="rect">
+            <a:avLst/>
+          </a:prstGeom>
+          <a:noFill/>
+        </p:spPr>
+        <p:txBody>
+          <a:bodyPr wrap="square" lIns="0" rIns="0" tIns="0" bIns="0">
+            <a:spAutoFit/>
+          </a:bodyPr>
+          <a:lstStyle/>
+          <a:p>
+            <a:pPr algn="l">
+              <a:lnSpc>
+                <a:spcPct val="115000"/>
+              </a:lnSpc>
+            </a:pPr>
+            <a:r>
+              <a:rPr sz="950" b="0">
+                <a:solidFill>
+                  <a:srgbClr val="5B7480"/>
+                </a:solidFill>
+                <a:latin typeface="Inter"/>
+              </a:rPr>
+              <a:t>UK</a:t>
+            </a:r>
+          </a:p>
+        </p:txBody>
+      </p:sp>
+      <p:sp>
+        <p:nvSpPr>
+          <p:cNvPr id="63" name="Rounded Rectangle 62"/>
+          <p:cNvSpPr/>
+          <p:nvPr/>
+        </p:nvSpPr>
+        <p:spPr>
+          <a:xfrm>
+            <a:off x="5461000" y="3041650"/>
+            <a:ext cx="330200" cy="139700"/>
+          </a:xfrm>
+          <a:prstGeom prst="roundRect">
+            <a:avLst>
+              <a:gd name="adj" fmla="val 27272"/>
+            </a:avLst>
+          </a:prstGeom>
+          <a:solidFill>
+            <a:srgbClr val="FDF0DF"/>
+          </a:solidFill>
+          <a:ln>
+            <a:noFill/>
+          </a:ln>
+          <a:effectLst/>
+        </p:spPr>
+        <p:style>
+          <a:lnRef idx="1">
+            <a:schemeClr val="accent1"/>
+          </a:lnRef>
+          <a:fillRef idx="3">
+            <a:schemeClr val="accent1"/>
+          </a:fillRef>
+          <a:effectRef idx="2">
+            <a:schemeClr val="accent1"/>
+          </a:effectRef>
+          <a:fontRef idx="minor">
+            <a:schemeClr val="lt1"/>
+          </a:fontRef>
+        </p:style>
+        <p:txBody>
+          <a:bodyPr rtlCol="0" anchor="ctr"/>
+          <a:lstStyle/>
+          <a:p>
+            <a:pPr algn="ctr"/>
+          </a:p>
+        </p:txBody>
+      </p:sp>
+      <p:sp>
+        <p:nvSpPr>
+          <p:cNvPr id="64" name="TextBox 63"/>
           <p:cNvSpPr txBox="1"/>
           <p:nvPr/>
         </p:nvSpPr>
@@ -11933,7 +12025,7 @@
       </p:sp>
       <p:sp>
         <p:nvSpPr>
-          <p:cNvPr id="63" name="TextBox 62"/>
+          <p:cNvPr id="65" name="TextBox 64"/>
           <p:cNvSpPr txBox="1"/>
           <p:nvPr/>
         </p:nvSpPr>
@@ -11972,7 +12064,7 @@
       </p:sp>
       <p:sp>
         <p:nvSpPr>
-          <p:cNvPr id="64" name="TextBox 63"/>
+          <p:cNvPr id="66" name="TextBox 65"/>
           <p:cNvSpPr txBox="1"/>
           <p:nvPr/>
         </p:nvSpPr>
@@ -12011,7 +12103,7 @@
       </p:sp>
       <p:sp>
         <p:nvSpPr>
-          <p:cNvPr id="65" name="TextBox 64"/>
+          <p:cNvPr id="67" name="TextBox 66"/>
           <p:cNvSpPr txBox="1"/>
           <p:nvPr/>
         </p:nvSpPr>
@@ -12050,7 +12142,7 @@
       </p:sp>
       <p:sp>
         <p:nvSpPr>
-          <p:cNvPr id="66" name="TextBox 65"/>
+          <p:cNvPr id="68" name="TextBox 67"/>
           <p:cNvSpPr txBox="1"/>
           <p:nvPr/>
         </p:nvSpPr>
@@ -12089,7 +12181,7 @@
       </p:sp>
       <p:sp>
         <p:nvSpPr>
-          <p:cNvPr id="67" name="TextBox 66"/>
+          <p:cNvPr id="69" name="TextBox 68"/>
           <p:cNvSpPr txBox="1"/>
           <p:nvPr/>
         </p:nvSpPr>
@@ -12128,7 +12220,7 @@
       </p:sp>
       <p:sp>
         <p:nvSpPr>
-          <p:cNvPr id="68" name="TextBox 67"/>
+          <p:cNvPr id="70" name="TextBox 69"/>
           <p:cNvSpPr txBox="1"/>
           <p:nvPr/>
         </p:nvSpPr>
@@ -12167,7 +12259,7 @@
       </p:sp>
       <p:sp>
         <p:nvSpPr>
-          <p:cNvPr id="69" name="TextBox 68"/>
+          <p:cNvPr id="71" name="TextBox 70"/>
           <p:cNvSpPr txBox="1"/>
           <p:nvPr/>
         </p:nvSpPr>
@@ -12206,7 +12298,7 @@
       </p:sp>
       <p:sp>
         <p:nvSpPr>
-          <p:cNvPr id="70" name="TextBox 69"/>
+          <p:cNvPr id="72" name="TextBox 71"/>
           <p:cNvSpPr txBox="1"/>
           <p:nvPr/>
         </p:nvSpPr>
@@ -12245,14 +12337,14 @@
       </p:sp>
       <p:sp>
         <p:nvSpPr>
-          <p:cNvPr id="71" name="Rounded Rectangle 70"/>
+          <p:cNvPr id="73" name="Rounded Rectangle 72"/>
           <p:cNvSpPr/>
           <p:nvPr/>
         </p:nvSpPr>
         <p:spPr>
           <a:xfrm>
             <a:off x="4508500" y="3371850"/>
-            <a:ext cx="495300" cy="139700"/>
+            <a:ext cx="622300" cy="139700"/>
           </a:xfrm>
           <a:prstGeom prst="roundRect">
             <a:avLst>
@@ -12291,14 +12383,14 @@
       </p:sp>
       <p:sp>
         <p:nvSpPr>
-          <p:cNvPr id="72" name="TextBox 71"/>
+          <p:cNvPr id="74" name="TextBox 73"/>
           <p:cNvSpPr txBox="1"/>
           <p:nvPr/>
         </p:nvSpPr>
         <p:spPr>
           <a:xfrm>
             <a:off x="4508500" y="3384550"/>
-            <a:ext cx="495300" cy="114300"/>
+            <a:ext cx="622300" cy="114300"/>
           </a:xfrm>
           <a:prstGeom prst="rect">
             <a:avLst/>
@@ -12323,14 +12415,14 @@
                 </a:solidFill>
                 <a:latin typeface="Inter"/>
               </a:rPr>
-              <a:t>PRIVÉ</a:t>
-            </a:r>
-          </a:p>
-        </p:txBody>
-      </p:sp>
-      <p:sp>
-        <p:nvSpPr>
-          <p:cNvPr id="73" name="Rounded Rectangle 72"/>
+              <a:t>PRIVAAT</a:t>
+            </a:r>
+          </a:p>
+        </p:txBody>
+      </p:sp>
+      <p:sp>
+        <p:nvSpPr>
+          <p:cNvPr id="75" name="Rounded Rectangle 74"/>
           <p:cNvSpPr/>
           <p:nvPr/>
         </p:nvSpPr>
@@ -12376,7 +12468,7 @@
       </p:sp>
       <p:sp>
         <p:nvSpPr>
-          <p:cNvPr id="74" name="TextBox 73"/>
+          <p:cNvPr id="76" name="TextBox 75"/>
           <p:cNvSpPr txBox="1"/>
           <p:nvPr/>
         </p:nvSpPr>
@@ -12415,7 +12507,7 @@
       </p:sp>
       <p:sp>
         <p:nvSpPr>
-          <p:cNvPr id="75" name="TextBox 74"/>
+          <p:cNvPr id="77" name="TextBox 76"/>
           <p:cNvSpPr txBox="1"/>
           <p:nvPr/>
         </p:nvSpPr>
@@ -12454,7 +12546,7 @@
       </p:sp>
       <p:sp>
         <p:nvSpPr>
-          <p:cNvPr id="76" name="TextBox 75"/>
+          <p:cNvPr id="78" name="TextBox 77"/>
           <p:cNvSpPr txBox="1"/>
           <p:nvPr/>
         </p:nvSpPr>
@@ -12493,7 +12585,7 @@
       </p:sp>
       <p:sp>
         <p:nvSpPr>
-          <p:cNvPr id="77" name="TextBox 76"/>
+          <p:cNvPr id="79" name="TextBox 78"/>
           <p:cNvSpPr txBox="1"/>
           <p:nvPr/>
         </p:nvSpPr>
@@ -12532,7 +12624,7 @@
       </p:sp>
       <p:sp>
         <p:nvSpPr>
-          <p:cNvPr id="78" name="TextBox 77"/>
+          <p:cNvPr id="80" name="TextBox 79"/>
           <p:cNvSpPr txBox="1"/>
           <p:nvPr/>
         </p:nvSpPr>
@@ -12571,7 +12663,7 @@
       </p:sp>
       <p:sp>
         <p:nvSpPr>
-          <p:cNvPr id="79" name="TextBox 78"/>
+          <p:cNvPr id="81" name="TextBox 80"/>
           <p:cNvSpPr txBox="1"/>
           <p:nvPr/>
         </p:nvSpPr>
@@ -12610,7 +12702,7 @@
       </p:sp>
       <p:sp>
         <p:nvSpPr>
-          <p:cNvPr id="80" name="TextBox 79"/>
+          <p:cNvPr id="82" name="TextBox 81"/>
           <p:cNvSpPr txBox="1"/>
           <p:nvPr/>
         </p:nvSpPr>
@@ -12649,7 +12741,7 @@
       </p:sp>
       <p:sp>
         <p:nvSpPr>
-          <p:cNvPr id="81" name="TextBox 80"/>
+          <p:cNvPr id="83" name="TextBox 82"/>
           <p:cNvSpPr txBox="1"/>
           <p:nvPr/>
         </p:nvSpPr>
@@ -12688,7 +12780,7 @@
       </p:sp>
       <p:sp>
         <p:nvSpPr>
-          <p:cNvPr id="82" name="TextBox 81"/>
+          <p:cNvPr id="84" name="TextBox 83"/>
           <p:cNvSpPr txBox="1"/>
           <p:nvPr/>
         </p:nvSpPr>
@@ -12727,7 +12819,7 @@
       </p:sp>
       <p:sp>
         <p:nvSpPr>
-          <p:cNvPr id="83" name="TextBox 82"/>
+          <p:cNvPr id="85" name="TextBox 84"/>
           <p:cNvSpPr txBox="1"/>
           <p:nvPr/>
         </p:nvSpPr>
@@ -12766,7 +12858,7 @@
       </p:sp>
       <p:sp>
         <p:nvSpPr>
-          <p:cNvPr id="84" name="TextBox 83"/>
+          <p:cNvPr id="86" name="TextBox 85"/>
           <p:cNvSpPr txBox="1"/>
           <p:nvPr/>
         </p:nvSpPr>
@@ -12805,7 +12897,7 @@
       </p:sp>
       <p:sp>
         <p:nvSpPr>
-          <p:cNvPr id="85" name="TextBox 84"/>
+          <p:cNvPr id="87" name="TextBox 86"/>
           <p:cNvSpPr txBox="1"/>
           <p:nvPr/>
         </p:nvSpPr>
@@ -12844,7 +12936,7 @@
       </p:sp>
       <p:sp>
         <p:nvSpPr>
-          <p:cNvPr id="86" name="TextBox 85"/>
+          <p:cNvPr id="88" name="TextBox 87"/>
           <p:cNvSpPr txBox="1"/>
           <p:nvPr/>
         </p:nvSpPr>
@@ -12883,7 +12975,7 @@
       </p:sp>
       <p:sp>
         <p:nvSpPr>
-          <p:cNvPr id="87" name="TextBox 86"/>
+          <p:cNvPr id="89" name="TextBox 88"/>
           <p:cNvSpPr txBox="1"/>
           <p:nvPr/>
         </p:nvSpPr>
@@ -12922,7 +13014,7 @@
       </p:sp>
       <p:sp>
         <p:nvSpPr>
-          <p:cNvPr id="88" name="TextBox 87"/>
+          <p:cNvPr id="90" name="TextBox 89"/>
           <p:cNvSpPr txBox="1"/>
           <p:nvPr/>
         </p:nvSpPr>
@@ -12961,7 +13053,7 @@
       </p:sp>
       <p:sp>
         <p:nvSpPr>
-          <p:cNvPr id="89" name="TextBox 88"/>
+          <p:cNvPr id="91" name="TextBox 90"/>
           <p:cNvSpPr txBox="1"/>
           <p:nvPr/>
         </p:nvSpPr>
@@ -13000,7 +13092,7 @@
       </p:sp>
       <p:sp>
         <p:nvSpPr>
-          <p:cNvPr id="90" name="TextBox 89"/>
+          <p:cNvPr id="92" name="TextBox 91"/>
           <p:cNvSpPr txBox="1"/>
           <p:nvPr/>
         </p:nvSpPr>
@@ -13039,7 +13131,7 @@
       </p:sp>
       <p:sp>
         <p:nvSpPr>
-          <p:cNvPr id="91" name="TextBox 90"/>
+          <p:cNvPr id="93" name="TextBox 92"/>
           <p:cNvSpPr txBox="1"/>
           <p:nvPr/>
         </p:nvSpPr>
@@ -13078,7 +13170,7 @@
       </p:sp>
       <p:sp>
         <p:nvSpPr>
-          <p:cNvPr id="92" name="TextBox 91"/>
+          <p:cNvPr id="94" name="TextBox 93"/>
           <p:cNvSpPr txBox="1"/>
           <p:nvPr/>
         </p:nvSpPr>
@@ -13117,7 +13209,7 @@
       </p:sp>
       <p:sp>
         <p:nvSpPr>
-          <p:cNvPr id="93" name="TextBox 92"/>
+          <p:cNvPr id="95" name="TextBox 94"/>
           <p:cNvSpPr txBox="1"/>
           <p:nvPr/>
         </p:nvSpPr>
@@ -13156,7 +13248,7 @@
       </p:sp>
       <p:sp>
         <p:nvSpPr>
-          <p:cNvPr id="94" name="TextBox 93"/>
+          <p:cNvPr id="96" name="TextBox 95"/>
           <p:cNvSpPr txBox="1"/>
           <p:nvPr/>
         </p:nvSpPr>
@@ -13195,14 +13287,14 @@
       </p:sp>
       <p:sp>
         <p:nvSpPr>
-          <p:cNvPr id="95" name="Rounded Rectangle 94"/>
+          <p:cNvPr id="97" name="Rounded Rectangle 96"/>
           <p:cNvSpPr/>
           <p:nvPr/>
         </p:nvSpPr>
         <p:spPr>
           <a:xfrm>
             <a:off x="4508500" y="4197350"/>
-            <a:ext cx="495300" cy="139700"/>
+            <a:ext cx="622300" cy="139700"/>
           </a:xfrm>
           <a:prstGeom prst="roundRect">
             <a:avLst>
@@ -13241,14 +13333,14 @@
       </p:sp>
       <p:sp>
         <p:nvSpPr>
-          <p:cNvPr id="96" name="TextBox 95"/>
+          <p:cNvPr id="98" name="TextBox 97"/>
           <p:cNvSpPr txBox="1"/>
           <p:nvPr/>
         </p:nvSpPr>
         <p:spPr>
           <a:xfrm>
             <a:off x="4508500" y="4210050"/>
-            <a:ext cx="495300" cy="114300"/>
+            <a:ext cx="622300" cy="114300"/>
           </a:xfrm>
           <a:prstGeom prst="rect">
             <a:avLst/>
@@ -13273,14 +13365,14 @@
                 </a:solidFill>
                 <a:latin typeface="Inter"/>
               </a:rPr>
-              <a:t>PRIVÉ</a:t>
-            </a:r>
-          </a:p>
-        </p:txBody>
-      </p:sp>
-      <p:sp>
-        <p:nvSpPr>
-          <p:cNvPr id="97" name="Rounded Rectangle 96"/>
+              <a:t>PRIVAAT</a:t>
+            </a:r>
+          </a:p>
+        </p:txBody>
+      </p:sp>
+      <p:sp>
+        <p:nvSpPr>
+          <p:cNvPr id="99" name="Rounded Rectangle 98"/>
           <p:cNvSpPr/>
           <p:nvPr/>
         </p:nvSpPr>
@@ -13326,7 +13418,7 @@
       </p:sp>
       <p:sp>
         <p:nvSpPr>
-          <p:cNvPr id="98" name="TextBox 97"/>
+          <p:cNvPr id="100" name="TextBox 99"/>
           <p:cNvSpPr txBox="1"/>
           <p:nvPr/>
         </p:nvSpPr>
@@ -13365,7 +13457,7 @@
       </p:sp>
       <p:sp>
         <p:nvSpPr>
-          <p:cNvPr id="99" name="TextBox 98"/>
+          <p:cNvPr id="101" name="TextBox 100"/>
           <p:cNvSpPr txBox="1"/>
           <p:nvPr/>
         </p:nvSpPr>
@@ -13404,7 +13496,7 @@
       </p:sp>
       <p:sp>
         <p:nvSpPr>
-          <p:cNvPr id="100" name="TextBox 99"/>
+          <p:cNvPr id="102" name="TextBox 101"/>
           <p:cNvSpPr txBox="1"/>
           <p:nvPr/>
         </p:nvSpPr>
@@ -13443,7 +13535,7 @@
       </p:sp>
       <p:sp>
         <p:nvSpPr>
-          <p:cNvPr id="101" name="TextBox 100"/>
+          <p:cNvPr id="103" name="TextBox 102"/>
           <p:cNvSpPr txBox="1"/>
           <p:nvPr/>
         </p:nvSpPr>
@@ -13482,7 +13574,7 @@
       </p:sp>
       <p:sp>
         <p:nvSpPr>
-          <p:cNvPr id="102" name="TextBox 101"/>
+          <p:cNvPr id="104" name="TextBox 103"/>
           <p:cNvSpPr txBox="1"/>
           <p:nvPr/>
         </p:nvSpPr>
@@ -13521,14 +13613,14 @@
       </p:sp>
       <p:sp>
         <p:nvSpPr>
-          <p:cNvPr id="103" name="Rounded Rectangle 102"/>
+          <p:cNvPr id="105" name="Rounded Rectangle 104"/>
           <p:cNvSpPr/>
           <p:nvPr/>
         </p:nvSpPr>
         <p:spPr>
           <a:xfrm>
             <a:off x="4508500" y="4362450"/>
-            <a:ext cx="495300" cy="139700"/>
+            <a:ext cx="622300" cy="139700"/>
           </a:xfrm>
           <a:prstGeom prst="roundRect">
             <a:avLst>
@@ -13567,14 +13659,14 @@
       </p:sp>
       <p:sp>
         <p:nvSpPr>
-          <p:cNvPr id="104" name="TextBox 103"/>
+          <p:cNvPr id="106" name="TextBox 105"/>
           <p:cNvSpPr txBox="1"/>
           <p:nvPr/>
         </p:nvSpPr>
         <p:spPr>
           <a:xfrm>
             <a:off x="4508500" y="4375150"/>
-            <a:ext cx="495300" cy="114300"/>
+            <a:ext cx="622300" cy="114300"/>
           </a:xfrm>
           <a:prstGeom prst="rect">
             <a:avLst/>
@@ -13599,14 +13691,14 @@
                 </a:solidFill>
                 <a:latin typeface="Inter"/>
               </a:rPr>
-              <a:t>PRIVÉ</a:t>
-            </a:r>
-          </a:p>
-        </p:txBody>
-      </p:sp>
-      <p:sp>
-        <p:nvSpPr>
-          <p:cNvPr id="105" name="Rounded Rectangle 104"/>
+              <a:t>PRIVAAT</a:t>
+            </a:r>
+          </a:p>
+        </p:txBody>
+      </p:sp>
+      <p:sp>
+        <p:nvSpPr>
+          <p:cNvPr id="107" name="Rounded Rectangle 106"/>
           <p:cNvSpPr/>
           <p:nvPr/>
         </p:nvSpPr>
@@ -13652,7 +13744,7 @@
       </p:sp>
       <p:sp>
         <p:nvSpPr>
-          <p:cNvPr id="106" name="TextBox 105"/>
+          <p:cNvPr id="108" name="TextBox 107"/>
           <p:cNvSpPr txBox="1"/>
           <p:nvPr/>
         </p:nvSpPr>
@@ -13691,7 +13783,7 @@
       </p:sp>
       <p:sp>
         <p:nvSpPr>
-          <p:cNvPr id="107" name="TextBox 106"/>
+          <p:cNvPr id="109" name="TextBox 108"/>
           <p:cNvSpPr txBox="1"/>
           <p:nvPr/>
         </p:nvSpPr>
@@ -13730,7 +13822,7 @@
       </p:sp>
       <p:sp>
         <p:nvSpPr>
-          <p:cNvPr id="108" name="TextBox 107"/>
+          <p:cNvPr id="110" name="TextBox 109"/>
           <p:cNvSpPr txBox="1"/>
           <p:nvPr/>
         </p:nvSpPr>
@@ -13769,7 +13861,7 @@
       </p:sp>
       <p:sp>
         <p:nvSpPr>
-          <p:cNvPr id="109" name="TextBox 108"/>
+          <p:cNvPr id="111" name="TextBox 110"/>
           <p:cNvSpPr txBox="1"/>
           <p:nvPr/>
         </p:nvSpPr>
@@ -13808,7 +13900,7 @@
       </p:sp>
       <p:sp>
         <p:nvSpPr>
-          <p:cNvPr id="110" name="TextBox 109"/>
+          <p:cNvPr id="112" name="TextBox 111"/>
           <p:cNvSpPr txBox="1"/>
           <p:nvPr/>
         </p:nvSpPr>
@@ -13847,7 +13939,7 @@
       </p:sp>
       <p:sp>
         <p:nvSpPr>
-          <p:cNvPr id="111" name="TextBox 110"/>
+          <p:cNvPr id="113" name="TextBox 112"/>
           <p:cNvSpPr txBox="1"/>
           <p:nvPr/>
         </p:nvSpPr>
@@ -13886,7 +13978,7 @@
       </p:sp>
       <p:sp>
         <p:nvSpPr>
-          <p:cNvPr id="112" name="Rounded Rectangle 111"/>
+          <p:cNvPr id="114" name="Rounded Rectangle 113"/>
           <p:cNvSpPr/>
           <p:nvPr/>
         </p:nvSpPr>
@@ -13932,7 +14024,7 @@
       </p:sp>
       <p:sp>
         <p:nvSpPr>
-          <p:cNvPr id="113" name="TextBox 112"/>
+          <p:cNvPr id="115" name="TextBox 114"/>
           <p:cNvSpPr txBox="1"/>
           <p:nvPr/>
         </p:nvSpPr>
@@ -13971,7 +14063,7 @@
       </p:sp>
       <p:sp>
         <p:nvSpPr>
-          <p:cNvPr id="114" name="TextBox 113"/>
+          <p:cNvPr id="116" name="TextBox 115"/>
           <p:cNvSpPr txBox="1"/>
           <p:nvPr/>
         </p:nvSpPr>
@@ -14010,7 +14102,7 @@
       </p:sp>
       <p:sp>
         <p:nvSpPr>
-          <p:cNvPr id="115" name="TextBox 114"/>
+          <p:cNvPr id="117" name="TextBox 116"/>
           <p:cNvSpPr txBox="1"/>
           <p:nvPr/>
         </p:nvSpPr>
@@ -14049,7 +14141,7 @@
       </p:sp>
       <p:sp>
         <p:nvSpPr>
-          <p:cNvPr id="116" name="TextBox 115"/>
+          <p:cNvPr id="118" name="TextBox 117"/>
           <p:cNvSpPr txBox="1"/>
           <p:nvPr/>
         </p:nvSpPr>
@@ -14088,7 +14180,7 @@
       </p:sp>
       <p:sp>
         <p:nvSpPr>
-          <p:cNvPr id="117" name="TextBox 116"/>
+          <p:cNvPr id="119" name="TextBox 118"/>
           <p:cNvSpPr txBox="1"/>
           <p:nvPr/>
         </p:nvSpPr>
@@ -14127,7 +14219,7 @@
       </p:sp>
       <p:sp>
         <p:nvSpPr>
-          <p:cNvPr id="118" name="TextBox 117"/>
+          <p:cNvPr id="120" name="TextBox 119"/>
           <p:cNvSpPr txBox="1"/>
           <p:nvPr/>
         </p:nvSpPr>
@@ -14166,7 +14258,7 @@
       </p:sp>
       <p:sp>
         <p:nvSpPr>
-          <p:cNvPr id="119" name="Rounded Rectangle 118"/>
+          <p:cNvPr id="121" name="Rounded Rectangle 120"/>
           <p:cNvSpPr/>
           <p:nvPr/>
         </p:nvSpPr>
@@ -14212,7 +14304,7 @@
       </p:sp>
       <p:sp>
         <p:nvSpPr>
-          <p:cNvPr id="120" name="TextBox 119"/>
+          <p:cNvPr id="122" name="TextBox 121"/>
           <p:cNvSpPr txBox="1"/>
           <p:nvPr/>
         </p:nvSpPr>
@@ -14251,7 +14343,7 @@
       </p:sp>
       <p:sp>
         <p:nvSpPr>
-          <p:cNvPr id="121" name="TextBox 120"/>
+          <p:cNvPr id="123" name="TextBox 122"/>
           <p:cNvSpPr txBox="1"/>
           <p:nvPr/>
         </p:nvSpPr>
@@ -14290,7 +14382,7 @@
       </p:sp>
       <p:sp>
         <p:nvSpPr>
-          <p:cNvPr id="122" name="TextBox 121"/>
+          <p:cNvPr id="124" name="TextBox 123"/>
           <p:cNvSpPr txBox="1"/>
           <p:nvPr/>
         </p:nvSpPr>
@@ -14329,7 +14421,7 @@
       </p:sp>
       <p:sp>
         <p:nvSpPr>
-          <p:cNvPr id="123" name="TextBox 122"/>
+          <p:cNvPr id="125" name="TextBox 124"/>
           <p:cNvSpPr txBox="1"/>
           <p:nvPr/>
         </p:nvSpPr>
@@ -14368,7 +14460,7 @@
       </p:sp>
       <p:sp>
         <p:nvSpPr>
-          <p:cNvPr id="124" name="TextBox 123"/>
+          <p:cNvPr id="126" name="TextBox 125"/>
           <p:cNvSpPr txBox="1"/>
           <p:nvPr/>
         </p:nvSpPr>
@@ -14407,14 +14499,14 @@
       </p:sp>
       <p:sp>
         <p:nvSpPr>
-          <p:cNvPr id="125" name="Rounded Rectangle 124"/>
+          <p:cNvPr id="127" name="Rounded Rectangle 126"/>
           <p:cNvSpPr/>
           <p:nvPr/>
         </p:nvSpPr>
         <p:spPr>
           <a:xfrm>
             <a:off x="4508500" y="4857750"/>
-            <a:ext cx="495300" cy="139700"/>
+            <a:ext cx="622300" cy="139700"/>
           </a:xfrm>
           <a:prstGeom prst="roundRect">
             <a:avLst>
@@ -14453,14 +14545,14 @@
       </p:sp>
       <p:sp>
         <p:nvSpPr>
-          <p:cNvPr id="126" name="TextBox 125"/>
+          <p:cNvPr id="128" name="TextBox 127"/>
           <p:cNvSpPr txBox="1"/>
           <p:nvPr/>
         </p:nvSpPr>
         <p:spPr>
           <a:xfrm>
             <a:off x="4508500" y="4870450"/>
-            <a:ext cx="495300" cy="114300"/>
+            <a:ext cx="622300" cy="114300"/>
           </a:xfrm>
           <a:prstGeom prst="rect">
             <a:avLst/>
@@ -14485,14 +14577,14 @@
                 </a:solidFill>
                 <a:latin typeface="Inter"/>
               </a:rPr>
-              <a:t>PRIVÉ</a:t>
-            </a:r>
-          </a:p>
-        </p:txBody>
-      </p:sp>
-      <p:sp>
-        <p:nvSpPr>
-          <p:cNvPr id="127" name="Rounded Rectangle 126"/>
+              <a:t>PRIVAAT</a:t>
+            </a:r>
+          </a:p>
+        </p:txBody>
+      </p:sp>
+      <p:sp>
+        <p:nvSpPr>
+          <p:cNvPr id="129" name="Rounded Rectangle 128"/>
           <p:cNvSpPr/>
           <p:nvPr/>
         </p:nvSpPr>
@@ -14538,7 +14630,7 @@
       </p:sp>
       <p:sp>
         <p:nvSpPr>
-          <p:cNvPr id="128" name="TextBox 127"/>
+          <p:cNvPr id="130" name="TextBox 129"/>
           <p:cNvSpPr txBox="1"/>
           <p:nvPr/>
         </p:nvSpPr>
@@ -14577,7 +14669,7 @@
       </p:sp>
       <p:sp>
         <p:nvSpPr>
-          <p:cNvPr id="129" name="TextBox 128"/>
+          <p:cNvPr id="131" name="TextBox 130"/>
           <p:cNvSpPr txBox="1"/>
           <p:nvPr/>
         </p:nvSpPr>
@@ -14616,7 +14708,7 @@
       </p:sp>
       <p:sp>
         <p:nvSpPr>
-          <p:cNvPr id="130" name="TextBox 129"/>
+          <p:cNvPr id="132" name="TextBox 131"/>
           <p:cNvSpPr txBox="1"/>
           <p:nvPr/>
         </p:nvSpPr>
@@ -14655,7 +14747,7 @@
       </p:sp>
       <p:sp>
         <p:nvSpPr>
-          <p:cNvPr id="131" name="Rectangle 130"/>
+          <p:cNvPr id="133" name="Rectangle 132"/>
           <p:cNvSpPr/>
           <p:nvPr/>
         </p:nvSpPr>
@@ -14699,7 +14791,7 @@
       </p:sp>
       <p:sp>
         <p:nvSpPr>
-          <p:cNvPr id="132" name="TextBox 131"/>
+          <p:cNvPr id="134" name="TextBox 133"/>
           <p:cNvSpPr txBox="1"/>
           <p:nvPr/>
         </p:nvSpPr>
@@ -14738,7 +14830,7 @@
       </p:sp>
       <p:sp>
         <p:nvSpPr>
-          <p:cNvPr id="133" name="TextBox 132"/>
+          <p:cNvPr id="135" name="TextBox 134"/>
           <p:cNvSpPr txBox="1"/>
           <p:nvPr/>
         </p:nvSpPr>
@@ -14777,7 +14869,7 @@
       </p:sp>
       <p:sp>
         <p:nvSpPr>
-          <p:cNvPr id="134" name="TextBox 133"/>
+          <p:cNvPr id="136" name="TextBox 135"/>
           <p:cNvSpPr txBox="1"/>
           <p:nvPr/>
         </p:nvSpPr>
@@ -14816,7 +14908,7 @@
       </p:sp>
       <p:sp>
         <p:nvSpPr>
-          <p:cNvPr id="135" name="Rectangle 134"/>
+          <p:cNvPr id="137" name="Rectangle 136"/>
           <p:cNvSpPr/>
           <p:nvPr/>
         </p:nvSpPr>
@@ -14860,7 +14952,7 @@
       </p:sp>
       <p:sp>
         <p:nvSpPr>
-          <p:cNvPr id="136" name="TextBox 135"/>
+          <p:cNvPr id="138" name="TextBox 137"/>
           <p:cNvSpPr txBox="1"/>
           <p:nvPr/>
         </p:nvSpPr>
@@ -14892,14 +14984,14 @@
                 </a:solidFill>
                 <a:latin typeface="Inter"/>
               </a:rPr>
-              <a:t>Q3 board knowledge doc, sep 2026. Afwijkende waarden op enkele regels t.o.v. Close (zie B4, open-vragen.md). BPP en Concorde staan niet in Close, aanmaakdatum onbekend. Aanmaakdatum overige regels uit Close, 24-09-2026.</a:t>
+              <a:t>Q3 board knowledge doc, sep 2026. Afwijkende waarden op enkele regels t.o.v. Close (zie B4, open-vragen.md). BPP en Concorde staan niet in Close, Q3-aanmaak bevestigd door Jeroen. Aanmaakdatum overige regels uit Close, 24-09-2026.</a:t>
             </a:r>
           </a:p>
         </p:txBody>
       </p:sp>
       <p:pic>
         <p:nvPicPr>
-          <p:cNvPr id="137" name="Picture 136" descr="logo_navy.png"/>
+          <p:cNvPr id="139" name="Picture 138" descr="logo_navy.png"/>
           <p:cNvPicPr>
             <a:picLocks noChangeAspect="1"/>
           </p:cNvPicPr>
@@ -14923,7 +15015,7 @@
       </p:pic>
       <p:sp>
         <p:nvSpPr>
-          <p:cNvPr id="138" name="TextBox 137"/>
+          <p:cNvPr id="140" name="TextBox 139"/>
           <p:cNvSpPr txBox="1"/>
           <p:nvPr/>
         </p:nvSpPr>

</xml_diff>

<commit_message>
De Beslissing-slide: alleen eindresultaten, geen onderzoeksproces
Op verzoek van Jeroen: caveat-tekst, correctiegeschiedenis en de
netwerkbeperking-toelichting eraf, dat hoort niet op een slide die
hij presenteert. Tabel kreeg een vierde kolom "Wat hoort hierbij"
met een korte omschrijving per marktrij (bv. "Particuliere
universiteiten (BPP, ULaw, Arden e.a.)") in plaats daarvan.

Cijfers zelf ongewijzigd. Volledige onderbouwing en correctiegeschiedenis
blijven staan in GTM/ICP/market-sizing-international/README.md en
Decisions/log.md.

Co-Authored-By: Claude Sonnet 5 <noreply@anthropic.com>
Claude-Session: https://claude.ai/code/session_01VJXex4xeGziE7UTBLmhoDk
</commit_message>
<xml_diff>
--- a/GTM/board-meeting-q3-2026/deck/eduface-board-q3-2026-bewerkbaar.pptx
+++ b/GTM/board-meeting-q3-2026/deck/eduface-board-q3-2026-bewerkbaar.pptx
@@ -18171,26 +18171,26 @@
         <p:spPr>
           <a:xfrm>
             <a:off x="762000" y="2476500"/>
-            <a:ext cx="3556000" cy="190500"/>
-          </a:xfrm>
-          <a:prstGeom prst="rect">
-            <a:avLst/>
-          </a:prstGeom>
-          <a:noFill/>
-        </p:spPr>
-        <p:txBody>
-          <a:bodyPr wrap="square" lIns="0" rIns="0" tIns="0" bIns="0">
-            <a:spAutoFit/>
-          </a:bodyPr>
-          <a:lstStyle/>
-          <a:p>
-            <a:pPr algn="l">
-              <a:lnSpc>
-                <a:spcPct val="115000"/>
-              </a:lnSpc>
-            </a:pPr>
-            <a:r>
-              <a:rPr sz="950" b="1">
+            <a:ext cx="2032000" cy="190500"/>
+          </a:xfrm>
+          <a:prstGeom prst="rect">
+            <a:avLst/>
+          </a:prstGeom>
+          <a:noFill/>
+        </p:spPr>
+        <p:txBody>
+          <a:bodyPr wrap="square" lIns="0" rIns="0" tIns="0" bIns="0">
+            <a:spAutoFit/>
+          </a:bodyPr>
+          <a:lstStyle/>
+          <a:p>
+            <a:pPr algn="l">
+              <a:lnSpc>
+                <a:spcPct val="115000"/>
+              </a:lnSpc>
+            </a:pPr>
+            <a:r>
+              <a:rPr sz="1000" b="1">
                 <a:solidFill>
                   <a:srgbClr val="5B7480"/>
                 </a:solidFill>
@@ -18209,32 +18209,71 @@
         </p:nvSpPr>
         <p:spPr>
           <a:xfrm>
-            <a:off x="4445000" y="2476500"/>
-            <a:ext cx="4318000" cy="190500"/>
-          </a:xfrm>
-          <a:prstGeom prst="rect">
-            <a:avLst/>
-          </a:prstGeom>
-          <a:noFill/>
-        </p:spPr>
-        <p:txBody>
-          <a:bodyPr wrap="square" lIns="0" rIns="0" tIns="0" bIns="0">
-            <a:spAutoFit/>
-          </a:bodyPr>
-          <a:lstStyle/>
-          <a:p>
-            <a:pPr algn="l">
-              <a:lnSpc>
-                <a:spcPct val="115000"/>
-              </a:lnSpc>
-            </a:pPr>
-            <a:r>
-              <a:rPr sz="950" b="1">
+            <a:off x="2921000" y="2476500"/>
+            <a:ext cx="4826000" cy="190500"/>
+          </a:xfrm>
+          <a:prstGeom prst="rect">
+            <a:avLst/>
+          </a:prstGeom>
+          <a:noFill/>
+        </p:spPr>
+        <p:txBody>
+          <a:bodyPr wrap="square" lIns="0" rIns="0" tIns="0" bIns="0">
+            <a:spAutoFit/>
+          </a:bodyPr>
+          <a:lstStyle/>
+          <a:p>
+            <a:pPr algn="l">
+              <a:lnSpc>
+                <a:spcPct val="115000"/>
+              </a:lnSpc>
+            </a:pPr>
+            <a:r>
+              <a:rPr sz="1000" b="1">
                 <a:solidFill>
                   <a:srgbClr val="5B7480"/>
                 </a:solidFill>
                 <a:latin typeface="Inter"/>
               </a:rPr>
+              <a:t>Wat hoort hierbij</a:t>
+            </a:r>
+          </a:p>
+        </p:txBody>
+      </p:sp>
+      <p:sp>
+        <p:nvSpPr>
+          <p:cNvPr id="10" name="TextBox 9"/>
+          <p:cNvSpPr txBox="1"/>
+          <p:nvPr/>
+        </p:nvSpPr>
+        <p:spPr>
+          <a:xfrm>
+            <a:off x="8001000" y="2476500"/>
+            <a:ext cx="1460500" cy="190500"/>
+          </a:xfrm>
+          <a:prstGeom prst="rect">
+            <a:avLst/>
+          </a:prstGeom>
+          <a:noFill/>
+        </p:spPr>
+        <p:txBody>
+          <a:bodyPr wrap="square" lIns="0" rIns="0" tIns="0" bIns="0">
+            <a:spAutoFit/>
+          </a:bodyPr>
+          <a:lstStyle/>
+          <a:p>
+            <a:pPr algn="r">
+              <a:lnSpc>
+                <a:spcPct val="115000"/>
+              </a:lnSpc>
+            </a:pPr>
+            <a:r>
+              <a:rPr sz="1000" b="1">
+                <a:solidFill>
+                  <a:srgbClr val="5B7480"/>
+                </a:solidFill>
+                <a:latin typeface="Inter"/>
+              </a:rPr>
               <a:t>Omvang</a:t>
             </a:r>
           </a:p>
@@ -18242,14 +18281,14 @@
       </p:sp>
       <p:sp>
         <p:nvSpPr>
-          <p:cNvPr id="10" name="TextBox 9"/>
-          <p:cNvSpPr txBox="1"/>
-          <p:nvPr/>
-        </p:nvSpPr>
-        <p:spPr>
-          <a:xfrm>
-            <a:off x="8890000" y="2476500"/>
-            <a:ext cx="2540000" cy="190500"/>
+          <p:cNvPr id="11" name="TextBox 10"/>
+          <p:cNvSpPr txBox="1"/>
+          <p:nvPr/>
+        </p:nvSpPr>
+        <p:spPr>
+          <a:xfrm>
+            <a:off x="9652000" y="2476500"/>
+            <a:ext cx="1778000" cy="190500"/>
           </a:xfrm>
           <a:prstGeom prst="rect">
             <a:avLst/>
@@ -18268,7 +18307,7 @@
               </a:lnSpc>
             </a:pPr>
             <a:r>
-              <a:rPr sz="950" b="1">
+              <a:rPr sz="1000" b="1">
                 <a:solidFill>
                   <a:srgbClr val="5B7480"/>
                 </a:solidFill>
@@ -18281,7 +18320,7 @@
       </p:sp>
       <p:sp>
         <p:nvSpPr>
-          <p:cNvPr id="11" name="Rectangle 10"/>
+          <p:cNvPr id="12" name="Rectangle 11"/>
           <p:cNvSpPr/>
           <p:nvPr/>
         </p:nvSpPr>
@@ -18325,77 +18364,116 @@
       </p:sp>
       <p:sp>
         <p:nvSpPr>
-          <p:cNvPr id="12" name="TextBox 11"/>
+          <p:cNvPr id="13" name="TextBox 12"/>
           <p:cNvSpPr txBox="1"/>
           <p:nvPr/>
         </p:nvSpPr>
         <p:spPr>
           <a:xfrm>
             <a:off x="762000" y="2755900"/>
-            <a:ext cx="3556000" cy="228600"/>
-          </a:xfrm>
-          <a:prstGeom prst="rect">
-            <a:avLst/>
-          </a:prstGeom>
-          <a:noFill/>
-        </p:spPr>
-        <p:txBody>
-          <a:bodyPr wrap="square" lIns="0" rIns="0" tIns="0" bIns="0">
-            <a:spAutoFit/>
-          </a:bodyPr>
-          <a:lstStyle/>
-          <a:p>
-            <a:pPr algn="l">
-              <a:lnSpc>
-                <a:spcPct val="115000"/>
-              </a:lnSpc>
-            </a:pPr>
-            <a:r>
-              <a:rPr sz="1250" b="0">
+            <a:ext cx="2032000" cy="279400"/>
+          </a:xfrm>
+          <a:prstGeom prst="rect">
+            <a:avLst/>
+          </a:prstGeom>
+          <a:noFill/>
+        </p:spPr>
+        <p:txBody>
+          <a:bodyPr wrap="square" lIns="0" rIns="0" tIns="0" bIns="0">
+            <a:spAutoFit/>
+          </a:bodyPr>
+          <a:lstStyle/>
+          <a:p>
+            <a:pPr algn="l">
+              <a:lnSpc>
+                <a:spcPct val="115000"/>
+              </a:lnSpc>
+            </a:pPr>
+            <a:r>
+              <a:rPr sz="1100" b="0">
                 <a:solidFill>
                   <a:srgbClr val="002333"/>
                 </a:solidFill>
                 <a:latin typeface="Inter"/>
               </a:rPr>
-              <a:t>Nederland, hoger onderwijs</a:t>
-            </a:r>
-          </a:p>
-        </p:txBody>
-      </p:sp>
-      <p:sp>
-        <p:nvSpPr>
-          <p:cNvPr id="13" name="TextBox 12"/>
-          <p:cNvSpPr txBox="1"/>
-          <p:nvPr/>
-        </p:nvSpPr>
-        <p:spPr>
-          <a:xfrm>
-            <a:off x="4445000" y="2755900"/>
-            <a:ext cx="4318000" cy="228600"/>
-          </a:xfrm>
-          <a:prstGeom prst="rect">
-            <a:avLst/>
-          </a:prstGeom>
-          <a:noFill/>
-        </p:spPr>
-        <p:txBody>
-          <a:bodyPr wrap="square" lIns="0" rIns="0" tIns="0" bIns="0">
-            <a:spAutoFit/>
-          </a:bodyPr>
-          <a:lstStyle/>
-          <a:p>
-            <a:pPr algn="l">
-              <a:lnSpc>
-                <a:spcPct val="115000"/>
-              </a:lnSpc>
-            </a:pPr>
-            <a:r>
-              <a:rPr sz="1250" b="0">
+              <a:t>Nederland</a:t>
+            </a:r>
+          </a:p>
+        </p:txBody>
+      </p:sp>
+      <p:sp>
+        <p:nvSpPr>
+          <p:cNvPr id="14" name="TextBox 13"/>
+          <p:cNvSpPr txBox="1"/>
+          <p:nvPr/>
+        </p:nvSpPr>
+        <p:spPr>
+          <a:xfrm>
+            <a:off x="2921000" y="2755900"/>
+            <a:ext cx="4826000" cy="279400"/>
+          </a:xfrm>
+          <a:prstGeom prst="rect">
+            <a:avLst/>
+          </a:prstGeom>
+          <a:noFill/>
+        </p:spPr>
+        <p:txBody>
+          <a:bodyPr wrap="square" lIns="0" rIns="0" tIns="0" bIns="0">
+            <a:spAutoFit/>
+          </a:bodyPr>
+          <a:lstStyle/>
+          <a:p>
+            <a:pPr algn="l">
+              <a:lnSpc>
+                <a:spcPct val="115000"/>
+              </a:lnSpc>
+            </a:pPr>
+            <a:r>
+              <a:rPr sz="1100" b="0">
                 <a:solidFill>
                   <a:srgbClr val="002333"/>
                 </a:solidFill>
                 <a:latin typeface="Inter"/>
               </a:rPr>
+              <a:t>Particuliere hogescholen (NCOI, LOI, Nyenrode e.a.)</a:t>
+            </a:r>
+          </a:p>
+        </p:txBody>
+      </p:sp>
+      <p:sp>
+        <p:nvSpPr>
+          <p:cNvPr id="15" name="TextBox 14"/>
+          <p:cNvSpPr txBox="1"/>
+          <p:nvPr/>
+        </p:nvSpPr>
+        <p:spPr>
+          <a:xfrm>
+            <a:off x="8001000" y="2755900"/>
+            <a:ext cx="1460500" cy="279400"/>
+          </a:xfrm>
+          <a:prstGeom prst="rect">
+            <a:avLst/>
+          </a:prstGeom>
+          <a:noFill/>
+        </p:spPr>
+        <p:txBody>
+          <a:bodyPr wrap="square" lIns="0" rIns="0" tIns="0" bIns="0">
+            <a:spAutoFit/>
+          </a:bodyPr>
+          <a:lstStyle/>
+          <a:p>
+            <a:pPr algn="r">
+              <a:lnSpc>
+                <a:spcPct val="115000"/>
+              </a:lnSpc>
+            </a:pPr>
+            <a:r>
+              <a:rPr sz="1100" b="0">
+                <a:solidFill>
+                  <a:srgbClr val="002333"/>
+                </a:solidFill>
+                <a:latin typeface="Inter"/>
+              </a:rPr>
               <a:t>127.024</a:t>
             </a:r>
           </a:p>
@@ -18403,14 +18481,14 @@
       </p:sp>
       <p:sp>
         <p:nvSpPr>
-          <p:cNvPr id="14" name="TextBox 13"/>
-          <p:cNvSpPr txBox="1"/>
-          <p:nvPr/>
-        </p:nvSpPr>
-        <p:spPr>
-          <a:xfrm>
-            <a:off x="8890000" y="2755900"/>
-            <a:ext cx="2540000" cy="228600"/>
+          <p:cNvPr id="16" name="TextBox 15"/>
+          <p:cNvSpPr txBox="1"/>
+          <p:nvPr/>
+        </p:nvSpPr>
+        <p:spPr>
+          <a:xfrm>
+            <a:off x="9652000" y="2755900"/>
+            <a:ext cx="1778000" cy="279400"/>
           </a:xfrm>
           <a:prstGeom prst="rect">
             <a:avLst/>
@@ -18429,7 +18507,7 @@
               </a:lnSpc>
             </a:pPr>
             <a:r>
-              <a:rPr sz="1250" b="0">
+              <a:rPr sz="1100" b="0">
                 <a:solidFill>
                   <a:srgbClr val="002333"/>
                 </a:solidFill>
@@ -18442,77 +18520,116 @@
       </p:sp>
       <p:sp>
         <p:nvSpPr>
-          <p:cNvPr id="15" name="TextBox 14"/>
-          <p:cNvSpPr txBox="1"/>
-          <p:nvPr/>
-        </p:nvSpPr>
-        <p:spPr>
-          <a:xfrm>
-            <a:off x="762000" y="3022600"/>
-            <a:ext cx="3556000" cy="228600"/>
-          </a:xfrm>
-          <a:prstGeom prst="rect">
-            <a:avLst/>
-          </a:prstGeom>
-          <a:noFill/>
-        </p:spPr>
-        <p:txBody>
-          <a:bodyPr wrap="square" lIns="0" rIns="0" tIns="0" bIns="0">
-            <a:spAutoFit/>
-          </a:bodyPr>
-          <a:lstStyle/>
-          <a:p>
-            <a:pPr algn="l">
-              <a:lnSpc>
-                <a:spcPct val="115000"/>
-              </a:lnSpc>
-            </a:pPr>
-            <a:r>
-              <a:rPr sz="1250" b="0">
+          <p:cNvPr id="17" name="TextBox 16"/>
+          <p:cNvSpPr txBox="1"/>
+          <p:nvPr/>
+        </p:nvSpPr>
+        <p:spPr>
+          <a:xfrm>
+            <a:off x="762000" y="3073400"/>
+            <a:ext cx="2032000" cy="279400"/>
+          </a:xfrm>
+          <a:prstGeom prst="rect">
+            <a:avLst/>
+          </a:prstGeom>
+          <a:noFill/>
+        </p:spPr>
+        <p:txBody>
+          <a:bodyPr wrap="square" lIns="0" rIns="0" tIns="0" bIns="0">
+            <a:spAutoFit/>
+          </a:bodyPr>
+          <a:lstStyle/>
+          <a:p>
+            <a:pPr algn="l">
+              <a:lnSpc>
+                <a:spcPct val="115000"/>
+              </a:lnSpc>
+            </a:pPr>
+            <a:r>
+              <a:rPr sz="1100" b="0">
                 <a:solidFill>
                   <a:srgbClr val="002333"/>
                 </a:solidFill>
                 <a:latin typeface="Inter"/>
               </a:rPr>
-              <a:t>VK, hoger onderwijs (particulier)</a:t>
-            </a:r>
-          </a:p>
-        </p:txBody>
-      </p:sp>
-      <p:sp>
-        <p:nvSpPr>
-          <p:cNvPr id="16" name="TextBox 15"/>
-          <p:cNvSpPr txBox="1"/>
-          <p:nvPr/>
-        </p:nvSpPr>
-        <p:spPr>
-          <a:xfrm>
-            <a:off x="4445000" y="3022600"/>
-            <a:ext cx="4318000" cy="228600"/>
-          </a:xfrm>
-          <a:prstGeom prst="rect">
-            <a:avLst/>
-          </a:prstGeom>
-          <a:noFill/>
-        </p:spPr>
-        <p:txBody>
-          <a:bodyPr wrap="square" lIns="0" rIns="0" tIns="0" bIns="0">
-            <a:spAutoFit/>
-          </a:bodyPr>
-          <a:lstStyle/>
-          <a:p>
-            <a:pPr algn="l">
-              <a:lnSpc>
-                <a:spcPct val="115000"/>
-              </a:lnSpc>
-            </a:pPr>
-            <a:r>
-              <a:rPr sz="1250" b="0">
+              <a:t>VK, hoger onderwijs</a:t>
+            </a:r>
+          </a:p>
+        </p:txBody>
+      </p:sp>
+      <p:sp>
+        <p:nvSpPr>
+          <p:cNvPr id="18" name="TextBox 17"/>
+          <p:cNvSpPr txBox="1"/>
+          <p:nvPr/>
+        </p:nvSpPr>
+        <p:spPr>
+          <a:xfrm>
+            <a:off x="2921000" y="3073400"/>
+            <a:ext cx="4826000" cy="279400"/>
+          </a:xfrm>
+          <a:prstGeom prst="rect">
+            <a:avLst/>
+          </a:prstGeom>
+          <a:noFill/>
+        </p:spPr>
+        <p:txBody>
+          <a:bodyPr wrap="square" lIns="0" rIns="0" tIns="0" bIns="0">
+            <a:spAutoFit/>
+          </a:bodyPr>
+          <a:lstStyle/>
+          <a:p>
+            <a:pPr algn="l">
+              <a:lnSpc>
+                <a:spcPct val="115000"/>
+              </a:lnSpc>
+            </a:pPr>
+            <a:r>
+              <a:rPr sz="1100" b="0">
                 <a:solidFill>
                   <a:srgbClr val="002333"/>
                 </a:solidFill>
                 <a:latin typeface="Inter"/>
               </a:rPr>
+              <a:t>Particuliere universiteiten (BPP, ULaw, Arden e.a.)</a:t>
+            </a:r>
+          </a:p>
+        </p:txBody>
+      </p:sp>
+      <p:sp>
+        <p:nvSpPr>
+          <p:cNvPr id="19" name="TextBox 18"/>
+          <p:cNvSpPr txBox="1"/>
+          <p:nvPr/>
+        </p:nvSpPr>
+        <p:spPr>
+          <a:xfrm>
+            <a:off x="8001000" y="3073400"/>
+            <a:ext cx="1460500" cy="279400"/>
+          </a:xfrm>
+          <a:prstGeom prst="rect">
+            <a:avLst/>
+          </a:prstGeom>
+          <a:noFill/>
+        </p:spPr>
+        <p:txBody>
+          <a:bodyPr wrap="square" lIns="0" rIns="0" tIns="0" bIns="0">
+            <a:spAutoFit/>
+          </a:bodyPr>
+          <a:lstStyle/>
+          <a:p>
+            <a:pPr algn="r">
+              <a:lnSpc>
+                <a:spcPct val="115000"/>
+              </a:lnSpc>
+            </a:pPr>
+            <a:r>
+              <a:rPr sz="1100" b="0">
+                <a:solidFill>
+                  <a:srgbClr val="002333"/>
+                </a:solidFill>
+                <a:latin typeface="Inter"/>
+              </a:rPr>
               <a:t>250.000-300.000</a:t>
             </a:r>
           </a:p>
@@ -18520,14 +18637,14 @@
       </p:sp>
       <p:sp>
         <p:nvSpPr>
-          <p:cNvPr id="17" name="TextBox 16"/>
-          <p:cNvSpPr txBox="1"/>
-          <p:nvPr/>
-        </p:nvSpPr>
-        <p:spPr>
-          <a:xfrm>
-            <a:off x="8890000" y="3022600"/>
-            <a:ext cx="2540000" cy="228600"/>
+          <p:cNvPr id="20" name="TextBox 19"/>
+          <p:cNvSpPr txBox="1"/>
+          <p:nvPr/>
+        </p:nvSpPr>
+        <p:spPr>
+          <a:xfrm>
+            <a:off x="9652000" y="3073400"/>
+            <a:ext cx="1778000" cy="279400"/>
           </a:xfrm>
           <a:prstGeom prst="rect">
             <a:avLst/>
@@ -18546,7 +18663,7 @@
               </a:lnSpc>
             </a:pPr>
             <a:r>
-              <a:rPr sz="1250" b="0">
+              <a:rPr sz="1100" b="0">
                 <a:solidFill>
                   <a:srgbClr val="002333"/>
                 </a:solidFill>
@@ -18559,77 +18676,116 @@
       </p:sp>
       <p:sp>
         <p:nvSpPr>
-          <p:cNvPr id="18" name="TextBox 17"/>
-          <p:cNvSpPr txBox="1"/>
-          <p:nvPr/>
-        </p:nvSpPr>
-        <p:spPr>
-          <a:xfrm>
-            <a:off x="762000" y="3289300"/>
-            <a:ext cx="3556000" cy="228600"/>
-          </a:xfrm>
-          <a:prstGeom prst="rect">
-            <a:avLst/>
-          </a:prstGeom>
-          <a:noFill/>
-        </p:spPr>
-        <p:txBody>
-          <a:bodyPr wrap="square" lIns="0" rIns="0" tIns="0" bIns="0">
-            <a:spAutoFit/>
-          </a:bodyPr>
-          <a:lstStyle/>
-          <a:p>
-            <a:pPr algn="l">
-              <a:lnSpc>
-                <a:spcPct val="115000"/>
-              </a:lnSpc>
-            </a:pPr>
-            <a:r>
-              <a:rPr sz="1250" b="0">
+          <p:cNvPr id="21" name="TextBox 20"/>
+          <p:cNvSpPr txBox="1"/>
+          <p:nvPr/>
+        </p:nvSpPr>
+        <p:spPr>
+          <a:xfrm>
+            <a:off x="762000" y="3390900"/>
+            <a:ext cx="2032000" cy="279400"/>
+          </a:xfrm>
+          <a:prstGeom prst="rect">
+            <a:avLst/>
+          </a:prstGeom>
+          <a:noFill/>
+        </p:spPr>
+        <p:txBody>
+          <a:bodyPr wrap="square" lIns="0" rIns="0" tIns="0" bIns="0">
+            <a:spAutoFit/>
+          </a:bodyPr>
+          <a:lstStyle/>
+          <a:p>
+            <a:pPr algn="l">
+              <a:lnSpc>
+                <a:spcPct val="115000"/>
+              </a:lnSpc>
+            </a:pPr>
+            <a:r>
+              <a:rPr sz="1100" b="0">
                 <a:solidFill>
                   <a:srgbClr val="002333"/>
                 </a:solidFill>
                 <a:latin typeface="Inter"/>
               </a:rPr>
-              <a:t>VK, apprenticeships (ITP)</a:t>
-            </a:r>
-          </a:p>
-        </p:txBody>
-      </p:sp>
-      <p:sp>
-        <p:nvSpPr>
-          <p:cNvPr id="19" name="TextBox 18"/>
-          <p:cNvSpPr txBox="1"/>
-          <p:nvPr/>
-        </p:nvSpPr>
-        <p:spPr>
-          <a:xfrm>
-            <a:off x="4445000" y="3289300"/>
-            <a:ext cx="4318000" cy="228600"/>
-          </a:xfrm>
-          <a:prstGeom prst="rect">
-            <a:avLst/>
-          </a:prstGeom>
-          <a:noFill/>
-        </p:spPr>
-        <p:txBody>
-          <a:bodyPr wrap="square" lIns="0" rIns="0" tIns="0" bIns="0">
-            <a:spAutoFit/>
-          </a:bodyPr>
-          <a:lstStyle/>
-          <a:p>
-            <a:pPr algn="l">
-              <a:lnSpc>
-                <a:spcPct val="115000"/>
-              </a:lnSpc>
-            </a:pPr>
-            <a:r>
-              <a:rPr sz="1250" b="0">
+              <a:t>VK, apprenticeships</a:t>
+            </a:r>
+          </a:p>
+        </p:txBody>
+      </p:sp>
+      <p:sp>
+        <p:nvSpPr>
+          <p:cNvPr id="22" name="TextBox 21"/>
+          <p:cNvSpPr txBox="1"/>
+          <p:nvPr/>
+        </p:nvSpPr>
+        <p:spPr>
+          <a:xfrm>
+            <a:off x="2921000" y="3390900"/>
+            <a:ext cx="4826000" cy="279400"/>
+          </a:xfrm>
+          <a:prstGeom prst="rect">
+            <a:avLst/>
+          </a:prstGeom>
+          <a:noFill/>
+        </p:spPr>
+        <p:txBody>
+          <a:bodyPr wrap="square" lIns="0" rIns="0" tIns="0" bIns="0">
+            <a:spAutoFit/>
+          </a:bodyPr>
+          <a:lstStyle/>
+          <a:p>
+            <a:pPr algn="l">
+              <a:lnSpc>
+                <a:spcPct val="115000"/>
+              </a:lnSpc>
+            </a:pPr>
+            <a:r>
+              <a:rPr sz="1100" b="0">
                 <a:solidFill>
                   <a:srgbClr val="002333"/>
                 </a:solidFill>
                 <a:latin typeface="Inter"/>
               </a:rPr>
+              <a:t>Particuliere praktijkopleiders (ITP's)</a:t>
+            </a:r>
+          </a:p>
+        </p:txBody>
+      </p:sp>
+      <p:sp>
+        <p:nvSpPr>
+          <p:cNvPr id="23" name="TextBox 22"/>
+          <p:cNvSpPr txBox="1"/>
+          <p:nvPr/>
+        </p:nvSpPr>
+        <p:spPr>
+          <a:xfrm>
+            <a:off x="8001000" y="3390900"/>
+            <a:ext cx="1460500" cy="279400"/>
+          </a:xfrm>
+          <a:prstGeom prst="rect">
+            <a:avLst/>
+          </a:prstGeom>
+          <a:noFill/>
+        </p:spPr>
+        <p:txBody>
+          <a:bodyPr wrap="square" lIns="0" rIns="0" tIns="0" bIns="0">
+            <a:spAutoFit/>
+          </a:bodyPr>
+          <a:lstStyle/>
+          <a:p>
+            <a:pPr algn="r">
+              <a:lnSpc>
+                <a:spcPct val="115000"/>
+              </a:lnSpc>
+            </a:pPr>
+            <a:r>
+              <a:rPr sz="1100" b="0">
+                <a:solidFill>
+                  <a:srgbClr val="002333"/>
+                </a:solidFill>
+                <a:latin typeface="Inter"/>
+              </a:rPr>
               <a:t>~520.000</a:t>
             </a:r>
           </a:p>
@@ -18637,14 +18793,14 @@
       </p:sp>
       <p:sp>
         <p:nvSpPr>
-          <p:cNvPr id="20" name="TextBox 19"/>
-          <p:cNvSpPr txBox="1"/>
-          <p:nvPr/>
-        </p:nvSpPr>
-        <p:spPr>
-          <a:xfrm>
-            <a:off x="8890000" y="3289300"/>
-            <a:ext cx="2540000" cy="228600"/>
+          <p:cNvPr id="24" name="TextBox 23"/>
+          <p:cNvSpPr txBox="1"/>
+          <p:nvPr/>
+        </p:nvSpPr>
+        <p:spPr>
+          <a:xfrm>
+            <a:off x="9652000" y="3390900"/>
+            <a:ext cx="1778000" cy="279400"/>
           </a:xfrm>
           <a:prstGeom prst="rect">
             <a:avLst/>
@@ -18663,7 +18819,7 @@
               </a:lnSpc>
             </a:pPr>
             <a:r>
-              <a:rPr sz="1250" b="0">
+              <a:rPr sz="1100" b="0">
                 <a:solidFill>
                   <a:srgbClr val="002333"/>
                 </a:solidFill>
@@ -18676,77 +18832,116 @@
       </p:sp>
       <p:sp>
         <p:nvSpPr>
-          <p:cNvPr id="21" name="TextBox 20"/>
-          <p:cNvSpPr txBox="1"/>
-          <p:nvPr/>
-        </p:nvSpPr>
-        <p:spPr>
-          <a:xfrm>
-            <a:off x="762000" y="3556000"/>
-            <a:ext cx="3556000" cy="228600"/>
-          </a:xfrm>
-          <a:prstGeom prst="rect">
-            <a:avLst/>
-          </a:prstGeom>
-          <a:noFill/>
-        </p:spPr>
-        <p:txBody>
-          <a:bodyPr wrap="square" lIns="0" rIns="0" tIns="0" bIns="0">
-            <a:spAutoFit/>
-          </a:bodyPr>
-          <a:lstStyle/>
-          <a:p>
-            <a:pPr algn="l">
-              <a:lnSpc>
-                <a:spcPct val="115000"/>
-              </a:lnSpc>
-            </a:pPr>
-            <a:r>
-              <a:rPr sz="1250" b="0">
+          <p:cNvPr id="25" name="TextBox 24"/>
+          <p:cNvSpPr txBox="1"/>
+          <p:nvPr/>
+        </p:nvSpPr>
+        <p:spPr>
+          <a:xfrm>
+            <a:off x="762000" y="3708400"/>
+            <a:ext cx="2032000" cy="279400"/>
+          </a:xfrm>
+          <a:prstGeom prst="rect">
+            <a:avLst/>
+          </a:prstGeom>
+          <a:noFill/>
+        </p:spPr>
+        <p:txBody>
+          <a:bodyPr wrap="square" lIns="0" rIns="0" tIns="0" bIns="0">
+            <a:spAutoFit/>
+          </a:bodyPr>
+          <a:lstStyle/>
+          <a:p>
+            <a:pPr algn="l">
+              <a:lnSpc>
+                <a:spcPct val="115000"/>
+              </a:lnSpc>
+            </a:pPr>
+            <a:r>
+              <a:rPr sz="1100" b="0">
                 <a:solidFill>
                   <a:srgbClr val="002333"/>
                 </a:solidFill>
                 <a:latin typeface="Inter"/>
               </a:rPr>
-              <a:t>VK, franchise-laag</a:t>
-            </a:r>
-          </a:p>
-        </p:txBody>
-      </p:sp>
-      <p:sp>
-        <p:nvSpPr>
-          <p:cNvPr id="22" name="TextBox 21"/>
-          <p:cNvSpPr txBox="1"/>
-          <p:nvPr/>
-        </p:nvSpPr>
-        <p:spPr>
-          <a:xfrm>
-            <a:off x="4445000" y="3556000"/>
-            <a:ext cx="4318000" cy="228600"/>
-          </a:xfrm>
-          <a:prstGeom prst="rect">
-            <a:avLst/>
-          </a:prstGeom>
-          <a:noFill/>
-        </p:spPr>
-        <p:txBody>
-          <a:bodyPr wrap="square" lIns="0" rIns="0" tIns="0" bIns="0">
-            <a:spAutoFit/>
-          </a:bodyPr>
-          <a:lstStyle/>
-          <a:p>
-            <a:pPr algn="l">
-              <a:lnSpc>
-                <a:spcPct val="115000"/>
-              </a:lnSpc>
-            </a:pPr>
-            <a:r>
-              <a:rPr sz="1250" b="0">
+              <a:t>VK, franchise</a:t>
+            </a:r>
+          </a:p>
+        </p:txBody>
+      </p:sp>
+      <p:sp>
+        <p:nvSpPr>
+          <p:cNvPr id="26" name="TextBox 25"/>
+          <p:cNvSpPr txBox="1"/>
+          <p:nvPr/>
+        </p:nvSpPr>
+        <p:spPr>
+          <a:xfrm>
+            <a:off x="2921000" y="3708400"/>
+            <a:ext cx="4826000" cy="279400"/>
+          </a:xfrm>
+          <a:prstGeom prst="rect">
+            <a:avLst/>
+          </a:prstGeom>
+          <a:noFill/>
+        </p:spPr>
+        <p:txBody>
+          <a:bodyPr wrap="square" lIns="0" rIns="0" tIns="0" bIns="0">
+            <a:spAutoFit/>
+          </a:bodyPr>
+          <a:lstStyle/>
+          <a:p>
+            <a:pPr algn="l">
+              <a:lnSpc>
+                <a:spcPct val="115000"/>
+              </a:lnSpc>
+            </a:pPr>
+            <a:r>
+              <a:rPr sz="1100" b="0">
                 <a:solidFill>
                   <a:srgbClr val="002333"/>
                 </a:solidFill>
                 <a:latin typeface="Inter"/>
               </a:rPr>
+              <a:t>Onderwijs uitbesteed aan particuliere partners</a:t>
+            </a:r>
+          </a:p>
+        </p:txBody>
+      </p:sp>
+      <p:sp>
+        <p:nvSpPr>
+          <p:cNvPr id="27" name="TextBox 26"/>
+          <p:cNvSpPr txBox="1"/>
+          <p:nvPr/>
+        </p:nvSpPr>
+        <p:spPr>
+          <a:xfrm>
+            <a:off x="8001000" y="3708400"/>
+            <a:ext cx="1460500" cy="279400"/>
+          </a:xfrm>
+          <a:prstGeom prst="rect">
+            <a:avLst/>
+          </a:prstGeom>
+          <a:noFill/>
+        </p:spPr>
+        <p:txBody>
+          <a:bodyPr wrap="square" lIns="0" rIns="0" tIns="0" bIns="0">
+            <a:spAutoFit/>
+          </a:bodyPr>
+          <a:lstStyle/>
+          <a:p>
+            <a:pPr algn="r">
+              <a:lnSpc>
+                <a:spcPct val="115000"/>
+              </a:lnSpc>
+            </a:pPr>
+            <a:r>
+              <a:rPr sz="1100" b="0">
+                <a:solidFill>
+                  <a:srgbClr val="002333"/>
+                </a:solidFill>
+                <a:latin typeface="Inter"/>
+              </a:rPr>
               <a:t>167.440</a:t>
             </a:r>
           </a:p>
@@ -18754,14 +18949,14 @@
       </p:sp>
       <p:sp>
         <p:nvSpPr>
-          <p:cNvPr id="23" name="TextBox 22"/>
-          <p:cNvSpPr txBox="1"/>
-          <p:nvPr/>
-        </p:nvSpPr>
-        <p:spPr>
-          <a:xfrm>
-            <a:off x="8890000" y="3556000"/>
-            <a:ext cx="2540000" cy="228600"/>
+          <p:cNvPr id="28" name="TextBox 27"/>
+          <p:cNvSpPr txBox="1"/>
+          <p:nvPr/>
+        </p:nvSpPr>
+        <p:spPr>
+          <a:xfrm>
+            <a:off x="9652000" y="3708400"/>
+            <a:ext cx="1778000" cy="279400"/>
           </a:xfrm>
           <a:prstGeom prst="rect">
             <a:avLst/>
@@ -18780,7 +18975,7 @@
               </a:lnSpc>
             </a:pPr>
             <a:r>
-              <a:rPr sz="1250" b="0">
+              <a:rPr sz="1100" b="0">
                 <a:solidFill>
                   <a:srgbClr val="002333"/>
                 </a:solidFill>
@@ -18793,77 +18988,116 @@
       </p:sp>
       <p:sp>
         <p:nvSpPr>
-          <p:cNvPr id="24" name="TextBox 23"/>
-          <p:cNvSpPr txBox="1"/>
-          <p:nvPr/>
-        </p:nvSpPr>
-        <p:spPr>
-          <a:xfrm>
-            <a:off x="762000" y="3822700"/>
-            <a:ext cx="3556000" cy="228600"/>
-          </a:xfrm>
-          <a:prstGeom prst="rect">
-            <a:avLst/>
-          </a:prstGeom>
-          <a:noFill/>
-        </p:spPr>
-        <p:txBody>
-          <a:bodyPr wrap="square" lIns="0" rIns="0" tIns="0" bIns="0">
-            <a:spAutoFit/>
-          </a:bodyPr>
-          <a:lstStyle/>
-          <a:p>
-            <a:pPr algn="l">
-              <a:lnSpc>
-                <a:spcPct val="115000"/>
-              </a:lnSpc>
-            </a:pPr>
-            <a:r>
-              <a:rPr sz="1250" b="0">
+          <p:cNvPr id="29" name="TextBox 28"/>
+          <p:cNvSpPr txBox="1"/>
+          <p:nvPr/>
+        </p:nvSpPr>
+        <p:spPr>
+          <a:xfrm>
+            <a:off x="762000" y="4025900"/>
+            <a:ext cx="2032000" cy="279400"/>
+          </a:xfrm>
+          <a:prstGeom prst="rect">
+            <a:avLst/>
+          </a:prstGeom>
+          <a:noFill/>
+        </p:spPr>
+        <p:txBody>
+          <a:bodyPr wrap="square" lIns="0" rIns="0" tIns="0" bIns="0">
+            <a:spAutoFit/>
+          </a:bodyPr>
+          <a:lstStyle/>
+          <a:p>
+            <a:pPr algn="l">
+              <a:lnSpc>
+                <a:spcPct val="115000"/>
+              </a:lnSpc>
+            </a:pPr>
+            <a:r>
+              <a:rPr sz="1100" b="0">
                 <a:solidFill>
                   <a:srgbClr val="002333"/>
                 </a:solidFill>
                 <a:latin typeface="Inter"/>
               </a:rPr>
-              <a:t>Verenigde Staten, particulier</a:t>
-            </a:r>
-          </a:p>
-        </p:txBody>
-      </p:sp>
-      <p:sp>
-        <p:nvSpPr>
-          <p:cNvPr id="25" name="TextBox 24"/>
-          <p:cNvSpPr txBox="1"/>
-          <p:nvPr/>
-        </p:nvSpPr>
-        <p:spPr>
-          <a:xfrm>
-            <a:off x="4445000" y="3822700"/>
-            <a:ext cx="4318000" cy="228600"/>
-          </a:xfrm>
-          <a:prstGeom prst="rect">
-            <a:avLst/>
-          </a:prstGeom>
-          <a:noFill/>
-        </p:spPr>
-        <p:txBody>
-          <a:bodyPr wrap="square" lIns="0" rIns="0" tIns="0" bIns="0">
-            <a:spAutoFit/>
-          </a:bodyPr>
-          <a:lstStyle/>
-          <a:p>
-            <a:pPr algn="l">
-              <a:lnSpc>
-                <a:spcPct val="115000"/>
-              </a:lnSpc>
-            </a:pPr>
-            <a:r>
-              <a:rPr sz="1250" b="0">
+              <a:t>Verenigde Staten</a:t>
+            </a:r>
+          </a:p>
+        </p:txBody>
+      </p:sp>
+      <p:sp>
+        <p:nvSpPr>
+          <p:cNvPr id="30" name="TextBox 29"/>
+          <p:cNvSpPr txBox="1"/>
+          <p:nvPr/>
+        </p:nvSpPr>
+        <p:spPr>
+          <a:xfrm>
+            <a:off x="2921000" y="4025900"/>
+            <a:ext cx="4826000" cy="279400"/>
+          </a:xfrm>
+          <a:prstGeom prst="rect">
+            <a:avLst/>
+          </a:prstGeom>
+          <a:noFill/>
+        </p:spPr>
+        <p:txBody>
+          <a:bodyPr wrap="square" lIns="0" rIns="0" tIns="0" bIns="0">
+            <a:spAutoFit/>
+          </a:bodyPr>
+          <a:lstStyle/>
+          <a:p>
+            <a:pPr algn="l">
+              <a:lnSpc>
+                <a:spcPct val="115000"/>
+              </a:lnSpc>
+            </a:pPr>
+            <a:r>
+              <a:rPr sz="1100" b="0">
                 <a:solidFill>
                   <a:srgbClr val="002333"/>
                 </a:solidFill>
                 <a:latin typeface="Inter"/>
               </a:rPr>
+              <a:t>For-profit en non-profit hoger onderwijs</a:t>
+            </a:r>
+          </a:p>
+        </p:txBody>
+      </p:sp>
+      <p:sp>
+        <p:nvSpPr>
+          <p:cNvPr id="31" name="TextBox 30"/>
+          <p:cNvSpPr txBox="1"/>
+          <p:nvPr/>
+        </p:nvSpPr>
+        <p:spPr>
+          <a:xfrm>
+            <a:off x="8001000" y="4025900"/>
+            <a:ext cx="1460500" cy="279400"/>
+          </a:xfrm>
+          <a:prstGeom prst="rect">
+            <a:avLst/>
+          </a:prstGeom>
+          <a:noFill/>
+        </p:spPr>
+        <p:txBody>
+          <a:bodyPr wrap="square" lIns="0" rIns="0" tIns="0" bIns="0">
+            <a:spAutoFit/>
+          </a:bodyPr>
+          <a:lstStyle/>
+          <a:p>
+            <a:pPr algn="r">
+              <a:lnSpc>
+                <a:spcPct val="115000"/>
+              </a:lnSpc>
+            </a:pPr>
+            <a:r>
+              <a:rPr sz="1100" b="0">
+                <a:solidFill>
+                  <a:srgbClr val="002333"/>
+                </a:solidFill>
+                <a:latin typeface="Inter"/>
+              </a:rPr>
               <a:t>~4,2 mln</a:t>
             </a:r>
           </a:p>
@@ -18871,14 +19105,14 @@
       </p:sp>
       <p:sp>
         <p:nvSpPr>
-          <p:cNvPr id="26" name="TextBox 25"/>
-          <p:cNvSpPr txBox="1"/>
-          <p:nvPr/>
-        </p:nvSpPr>
-        <p:spPr>
-          <a:xfrm>
-            <a:off x="8890000" y="3822700"/>
-            <a:ext cx="2540000" cy="228600"/>
+          <p:cNvPr id="32" name="TextBox 31"/>
+          <p:cNvSpPr txBox="1"/>
+          <p:nvPr/>
+        </p:nvSpPr>
+        <p:spPr>
+          <a:xfrm>
+            <a:off x="9652000" y="4025900"/>
+            <a:ext cx="1778000" cy="279400"/>
           </a:xfrm>
           <a:prstGeom prst="rect">
             <a:avLst/>
@@ -18897,7 +19131,7 @@
               </a:lnSpc>
             </a:pPr>
             <a:r>
-              <a:rPr sz="1250" b="0">
+              <a:rPr sz="1100" b="0">
                 <a:solidFill>
                   <a:srgbClr val="002333"/>
                 </a:solidFill>
@@ -18910,77 +19144,116 @@
       </p:sp>
       <p:sp>
         <p:nvSpPr>
-          <p:cNvPr id="27" name="TextBox 26"/>
-          <p:cNvSpPr txBox="1"/>
-          <p:nvPr/>
-        </p:nvSpPr>
-        <p:spPr>
-          <a:xfrm>
-            <a:off x="762000" y="4089400"/>
-            <a:ext cx="3556000" cy="228600"/>
-          </a:xfrm>
-          <a:prstGeom prst="rect">
-            <a:avLst/>
-          </a:prstGeom>
-          <a:noFill/>
-        </p:spPr>
-        <p:txBody>
-          <a:bodyPr wrap="square" lIns="0" rIns="0" tIns="0" bIns="0">
-            <a:spAutoFit/>
-          </a:bodyPr>
-          <a:lstStyle/>
-          <a:p>
-            <a:pPr algn="l">
-              <a:lnSpc>
-                <a:spcPct val="115000"/>
-              </a:lnSpc>
-            </a:pPr>
-            <a:r>
-              <a:rPr sz="1250" b="0">
+          <p:cNvPr id="33" name="TextBox 32"/>
+          <p:cNvSpPr txBox="1"/>
+          <p:nvPr/>
+        </p:nvSpPr>
+        <p:spPr>
+          <a:xfrm>
+            <a:off x="762000" y="4343400"/>
+            <a:ext cx="2032000" cy="279400"/>
+          </a:xfrm>
+          <a:prstGeom prst="rect">
+            <a:avLst/>
+          </a:prstGeom>
+          <a:noFill/>
+        </p:spPr>
+        <p:txBody>
+          <a:bodyPr wrap="square" lIns="0" rIns="0" tIns="0" bIns="0">
+            <a:spAutoFit/>
+          </a:bodyPr>
+          <a:lstStyle/>
+          <a:p>
+            <a:pPr algn="l">
+              <a:lnSpc>
+                <a:spcPct val="115000"/>
+              </a:lnSpc>
+            </a:pPr>
+            <a:r>
+              <a:rPr sz="1100" b="0">
                 <a:solidFill>
                   <a:srgbClr val="002333"/>
                 </a:solidFill>
                 <a:latin typeface="Inter"/>
               </a:rPr>
-              <a:t>Europa, overig (niet herzien)</a:t>
-            </a:r>
-          </a:p>
-        </p:txBody>
-      </p:sp>
-      <p:sp>
-        <p:nvSpPr>
-          <p:cNvPr id="28" name="TextBox 27"/>
-          <p:cNvSpPr txBox="1"/>
-          <p:nvPr/>
-        </p:nvSpPr>
-        <p:spPr>
-          <a:xfrm>
-            <a:off x="4445000" y="4089400"/>
-            <a:ext cx="4318000" cy="228600"/>
-          </a:xfrm>
-          <a:prstGeom prst="rect">
-            <a:avLst/>
-          </a:prstGeom>
-          <a:noFill/>
-        </p:spPr>
-        <p:txBody>
-          <a:bodyPr wrap="square" lIns="0" rIns="0" tIns="0" bIns="0">
-            <a:spAutoFit/>
-          </a:bodyPr>
-          <a:lstStyle/>
-          <a:p>
-            <a:pPr algn="l">
-              <a:lnSpc>
-                <a:spcPct val="115000"/>
-              </a:lnSpc>
-            </a:pPr>
-            <a:r>
-              <a:rPr sz="1250" b="0">
+              <a:t>Europa, overig</a:t>
+            </a:r>
+          </a:p>
+        </p:txBody>
+      </p:sp>
+      <p:sp>
+        <p:nvSpPr>
+          <p:cNvPr id="34" name="TextBox 33"/>
+          <p:cNvSpPr txBox="1"/>
+          <p:nvPr/>
+        </p:nvSpPr>
+        <p:spPr>
+          <a:xfrm>
+            <a:off x="2921000" y="4343400"/>
+            <a:ext cx="4826000" cy="279400"/>
+          </a:xfrm>
+          <a:prstGeom prst="rect">
+            <a:avLst/>
+          </a:prstGeom>
+          <a:noFill/>
+        </p:spPr>
+        <p:txBody>
+          <a:bodyPr wrap="square" lIns="0" rIns="0" tIns="0" bIns="0">
+            <a:spAutoFit/>
+          </a:bodyPr>
+          <a:lstStyle/>
+          <a:p>
+            <a:pPr algn="l">
+              <a:lnSpc>
+                <a:spcPct val="115000"/>
+              </a:lnSpc>
+            </a:pPr>
+            <a:r>
+              <a:rPr sz="1100" b="0">
                 <a:solidFill>
                   <a:srgbClr val="002333"/>
                 </a:solidFill>
                 <a:latin typeface="Inter"/>
               </a:rPr>
+              <a:t>Particulier hoger onderwijs, rest van Europa</a:t>
+            </a:r>
+          </a:p>
+        </p:txBody>
+      </p:sp>
+      <p:sp>
+        <p:nvSpPr>
+          <p:cNvPr id="35" name="TextBox 34"/>
+          <p:cNvSpPr txBox="1"/>
+          <p:nvPr/>
+        </p:nvSpPr>
+        <p:spPr>
+          <a:xfrm>
+            <a:off x="8001000" y="4343400"/>
+            <a:ext cx="1460500" cy="279400"/>
+          </a:xfrm>
+          <a:prstGeom prst="rect">
+            <a:avLst/>
+          </a:prstGeom>
+          <a:noFill/>
+        </p:spPr>
+        <p:txBody>
+          <a:bodyPr wrap="square" lIns="0" rIns="0" tIns="0" bIns="0">
+            <a:spAutoFit/>
+          </a:bodyPr>
+          <a:lstStyle/>
+          <a:p>
+            <a:pPr algn="r">
+              <a:lnSpc>
+                <a:spcPct val="115000"/>
+              </a:lnSpc>
+            </a:pPr>
+            <a:r>
+              <a:rPr sz="1100" b="0">
+                <a:solidFill>
+                  <a:srgbClr val="002333"/>
+                </a:solidFill>
+                <a:latin typeface="Inter"/>
+              </a:rPr>
               <a:t>3,6 mln</a:t>
             </a:r>
           </a:p>
@@ -18988,14 +19261,14 @@
       </p:sp>
       <p:sp>
         <p:nvSpPr>
-          <p:cNvPr id="29" name="TextBox 28"/>
-          <p:cNvSpPr txBox="1"/>
-          <p:nvPr/>
-        </p:nvSpPr>
-        <p:spPr>
-          <a:xfrm>
-            <a:off x="8890000" y="4089400"/>
-            <a:ext cx="2540000" cy="228600"/>
+          <p:cNvPr id="36" name="TextBox 35"/>
+          <p:cNvSpPr txBox="1"/>
+          <p:nvPr/>
+        </p:nvSpPr>
+        <p:spPr>
+          <a:xfrm>
+            <a:off x="9652000" y="4343400"/>
+            <a:ext cx="1778000" cy="279400"/>
           </a:xfrm>
           <a:prstGeom prst="rect">
             <a:avLst/>
@@ -19014,7 +19287,7 @@
               </a:lnSpc>
             </a:pPr>
             <a:r>
-              <a:rPr sz="1250" b="0">
+              <a:rPr sz="1100" b="0">
                 <a:solidFill>
                   <a:srgbClr val="002333"/>
                 </a:solidFill>
@@ -19027,46 +19300,7 @@
       </p:sp>
       <p:sp>
         <p:nvSpPr>
-          <p:cNvPr id="30" name="TextBox 29"/>
-          <p:cNvSpPr txBox="1"/>
-          <p:nvPr/>
-        </p:nvSpPr>
-        <p:spPr>
-          <a:xfrm>
-            <a:off x="762000" y="4394200"/>
-            <a:ext cx="10668000" cy="381000"/>
-          </a:xfrm>
-          <a:prstGeom prst="rect">
-            <a:avLst/>
-          </a:prstGeom>
-          <a:noFill/>
-        </p:spPr>
-        <p:txBody>
-          <a:bodyPr wrap="square" lIns="0" rIns="0" tIns="0" bIns="0">
-            <a:spAutoFit/>
-          </a:bodyPr>
-          <a:lstStyle/>
-          <a:p>
-            <a:pPr algn="l">
-              <a:lnSpc>
-                <a:spcPct val="130000"/>
-              </a:lnSpc>
-            </a:pPr>
-            <a:r>
-              <a:rPr sz="950" b="0">
-                <a:solidFill>
-                  <a:srgbClr val="5B7480"/>
-                </a:solidFill>
-                <a:latin typeface="Inter"/>
-              </a:rPr>
-              <a:t>Officiele registraties (DUO, HESA) tellen alleen wie zich laat erkennen/designeren en missen grote merken (BPP+ULaw+Arden al 90.000+ VK): NL/VK gebruiken daarom de bredere schatting. 0 particuliere deals gewonnen tot nu toe (Tio, ICM, CMS Vocational alle Lost); dit is TAM, geen omzet.</a:t>
-            </a:r>
-          </a:p>
-        </p:txBody>
-      </p:sp>
-      <p:sp>
-        <p:nvSpPr>
-          <p:cNvPr id="31" name="Rectangle 30"/>
+          <p:cNvPr id="37" name="Rectangle 36"/>
           <p:cNvSpPr/>
           <p:nvPr/>
         </p:nvSpPr>
@@ -19110,7 +19344,7 @@
       </p:sp>
       <p:sp>
         <p:nvSpPr>
-          <p:cNvPr id="32" name="TextBox 31"/>
+          <p:cNvPr id="38" name="TextBox 37"/>
           <p:cNvSpPr txBox="1"/>
           <p:nvPr/>
         </p:nvSpPr>
@@ -19142,14 +19376,14 @@
                 </a:solidFill>
                 <a:latin typeface="Inter"/>
               </a:rPr>
-              <a:t>Marktomvang tweemaal herzien op 24-09-2026: officiele DUO/HESA-registraties bleken de markt te ondertellen t.o.v. bekende merken (BPP, ULaw, Arden, GBS, NCOI). HESA/NCES/Eurostat grotendeels geblokkeerd in de sessie.</a:t>
+              <a:t>Bronnen: Eurostat, HESA, DfE, NAO, NCES/IPEDS (2022-2025).</a:t>
             </a:r>
           </a:p>
         </p:txBody>
       </p:sp>
       <p:pic>
         <p:nvPicPr>
-          <p:cNvPr id="33" name="Picture 32" descr="logo_navy.png"/>
+          <p:cNvPr id="39" name="Picture 38" descr="logo_navy.png"/>
           <p:cNvPicPr>
             <a:picLocks noChangeAspect="1"/>
           </p:cNvPicPr>
@@ -19173,7 +19407,7 @@
       </p:pic>
       <p:sp>
         <p:nvSpPr>
-          <p:cNvPr id="34" name="TextBox 33"/>
+          <p:cNvPr id="40" name="TextBox 39"/>
           <p:cNvSpPr txBox="1"/>
           <p:nvPr/>
         </p:nvSpPr>

</xml_diff>